<commit_message>
slides: 行間改善 (space_after 14pt) + PDF 版同梱 (ja/en) — PowerPoint COM で視覚検証済 (10 枚×2、崩れなし)
</commit_message>
<xml_diff>
--- a/slides/llcore_findings_2026_en.pptx
+++ b/slides/llcore_findings_2026_en.pptx
@@ -3379,7 +3379,11 @@
           </a:bodyPr>
           <a:lstStyle/>
           <a:p>
-            <a:pPr algn="l"/>
+            <a:pPr algn="l">
+              <a:spcAft>
+                <a:spcPts val="1400"/>
+              </a:spcAft>
+            </a:pPr>
             <a:r>
               <a:rPr sz="1900" b="0">
                 <a:solidFill>
@@ -3391,7 +3395,11 @@
             </a:r>
           </a:p>
           <a:p>
-            <a:pPr algn="l"/>
+            <a:pPr algn="l">
+              <a:spcAft>
+                <a:spcPts val="1400"/>
+              </a:spcAft>
+            </a:pPr>
             <a:r>
               <a:rPr sz="1900" b="0">
                 <a:solidFill>
@@ -3403,7 +3411,11 @@
             </a:r>
           </a:p>
           <a:p>
-            <a:pPr algn="l"/>
+            <a:pPr algn="l">
+              <a:spcAft>
+                <a:spcPts val="1400"/>
+              </a:spcAft>
+            </a:pPr>
             <a:r>
               <a:rPr sz="1900" b="0">
                 <a:solidFill>
@@ -3415,7 +3427,11 @@
             </a:r>
           </a:p>
           <a:p>
-            <a:pPr algn="l"/>
+            <a:pPr algn="l">
+              <a:spcAft>
+                <a:spcPts val="1400"/>
+              </a:spcAft>
+            </a:pPr>
             <a:r>
               <a:rPr sz="1900" b="0">
                 <a:solidFill>
@@ -3427,7 +3443,11 @@
             </a:r>
           </a:p>
           <a:p>
-            <a:pPr algn="l"/>
+            <a:pPr algn="l">
+              <a:spcAft>
+                <a:spcPts val="1400"/>
+              </a:spcAft>
+            </a:pPr>
             <a:r>
               <a:rPr sz="1900" b="0">
                 <a:solidFill>
@@ -3593,7 +3613,11 @@
           </a:bodyPr>
           <a:lstStyle/>
           <a:p>
-            <a:pPr algn="l"/>
+            <a:pPr algn="l">
+              <a:spcAft>
+                <a:spcPts val="1400"/>
+              </a:spcAft>
+            </a:pPr>
             <a:r>
               <a:rPr sz="1900" b="0">
                 <a:solidFill>
@@ -3605,7 +3629,11 @@
             </a:r>
           </a:p>
           <a:p>
-            <a:pPr algn="l"/>
+            <a:pPr algn="l">
+              <a:spcAft>
+                <a:spcPts val="1400"/>
+              </a:spcAft>
+            </a:pPr>
             <a:r>
               <a:rPr sz="1900" b="0">
                 <a:solidFill>
@@ -3617,7 +3645,11 @@
             </a:r>
           </a:p>
           <a:p>
-            <a:pPr algn="l"/>
+            <a:pPr algn="l">
+              <a:spcAft>
+                <a:spcPts val="1400"/>
+              </a:spcAft>
+            </a:pPr>
             <a:r>
               <a:rPr sz="1900" b="0">
                 <a:solidFill>
@@ -3629,7 +3661,11 @@
             </a:r>
           </a:p>
           <a:p>
-            <a:pPr algn="l"/>
+            <a:pPr algn="l">
+              <a:spcAft>
+                <a:spcPts val="1400"/>
+              </a:spcAft>
+            </a:pPr>
             <a:r>
               <a:rPr sz="1900" b="0">
                 <a:solidFill>
@@ -3795,7 +3831,11 @@
           </a:bodyPr>
           <a:lstStyle/>
           <a:p>
-            <a:pPr algn="l"/>
+            <a:pPr algn="l">
+              <a:spcAft>
+                <a:spcPts val="1400"/>
+              </a:spcAft>
+            </a:pPr>
             <a:r>
               <a:rPr sz="1900" b="0">
                 <a:solidFill>
@@ -3807,7 +3847,11 @@
             </a:r>
           </a:p>
           <a:p>
-            <a:pPr algn="l"/>
+            <a:pPr algn="l">
+              <a:spcAft>
+                <a:spcPts val="1400"/>
+              </a:spcAft>
+            </a:pPr>
             <a:r>
               <a:rPr sz="1900" b="0">
                 <a:solidFill>
@@ -3819,7 +3863,11 @@
             </a:r>
           </a:p>
           <a:p>
-            <a:pPr algn="l"/>
+            <a:pPr algn="l">
+              <a:spcAft>
+                <a:spcPts val="1400"/>
+              </a:spcAft>
+            </a:pPr>
             <a:r>
               <a:rPr sz="1900" b="0">
                 <a:solidFill>
@@ -3831,7 +3879,11 @@
             </a:r>
           </a:p>
           <a:p>
-            <a:pPr algn="l"/>
+            <a:pPr algn="l">
+              <a:spcAft>
+                <a:spcPts val="1400"/>
+              </a:spcAft>
+            </a:pPr>
             <a:r>
               <a:rPr sz="1900" b="0">
                 <a:solidFill>
@@ -4032,7 +4084,11 @@
           </a:bodyPr>
           <a:lstStyle/>
           <a:p>
-            <a:pPr algn="l"/>
+            <a:pPr algn="l">
+              <a:spcAft>
+                <a:spcPts val="1400"/>
+              </a:spcAft>
+            </a:pPr>
             <a:r>
               <a:rPr sz="1900" b="0">
                 <a:solidFill>
@@ -4044,7 +4100,11 @@
             </a:r>
           </a:p>
           <a:p>
-            <a:pPr algn="l"/>
+            <a:pPr algn="l">
+              <a:spcAft>
+                <a:spcPts val="1400"/>
+              </a:spcAft>
+            </a:pPr>
             <a:r>
               <a:rPr sz="1900" b="0">
                 <a:solidFill>
@@ -4056,7 +4116,11 @@
             </a:r>
           </a:p>
           <a:p>
-            <a:pPr algn="l"/>
+            <a:pPr algn="l">
+              <a:spcAft>
+                <a:spcPts val="1400"/>
+              </a:spcAft>
+            </a:pPr>
             <a:r>
               <a:rPr sz="1900" b="0">
                 <a:solidFill>
@@ -4068,7 +4132,11 @@
             </a:r>
           </a:p>
           <a:p>
-            <a:pPr algn="l"/>
+            <a:pPr algn="l">
+              <a:spcAft>
+                <a:spcPts val="1400"/>
+              </a:spcAft>
+            </a:pPr>
             <a:r>
               <a:rPr sz="1900" b="0">
                 <a:solidFill>
@@ -4080,7 +4148,11 @@
             </a:r>
           </a:p>
           <a:p>
-            <a:pPr algn="l"/>
+            <a:pPr algn="l">
+              <a:spcAft>
+                <a:spcPts val="1400"/>
+              </a:spcAft>
+            </a:pPr>
             <a:r>
               <a:rPr sz="1900" b="0">
                 <a:solidFill>
@@ -4246,7 +4318,11 @@
           </a:bodyPr>
           <a:lstStyle/>
           <a:p>
-            <a:pPr algn="l"/>
+            <a:pPr algn="l">
+              <a:spcAft>
+                <a:spcPts val="1400"/>
+              </a:spcAft>
+            </a:pPr>
             <a:r>
               <a:rPr sz="1900" b="0">
                 <a:solidFill>
@@ -4258,7 +4334,11 @@
             </a:r>
           </a:p>
           <a:p>
-            <a:pPr lvl="1" algn="l"/>
+            <a:pPr lvl="1" algn="l">
+              <a:spcAft>
+                <a:spcPts val="1400"/>
+              </a:spcAft>
+            </a:pPr>
             <a:r>
               <a:rPr sz="1900" b="0">
                 <a:solidFill>
@@ -4270,7 +4350,11 @@
             </a:r>
           </a:p>
           <a:p>
-            <a:pPr algn="l"/>
+            <a:pPr algn="l">
+              <a:spcAft>
+                <a:spcPts val="1400"/>
+              </a:spcAft>
+            </a:pPr>
             <a:r>
               <a:rPr sz="1900" b="0">
                 <a:solidFill>
@@ -4282,7 +4366,11 @@
             </a:r>
           </a:p>
           <a:p>
-            <a:pPr algn="l"/>
+            <a:pPr algn="l">
+              <a:spcAft>
+                <a:spcPts val="1400"/>
+              </a:spcAft>
+            </a:pPr>
             <a:r>
               <a:rPr sz="1900" b="0">
                 <a:solidFill>
@@ -4294,7 +4382,11 @@
             </a:r>
           </a:p>
           <a:p>
-            <a:pPr algn="l"/>
+            <a:pPr algn="l">
+              <a:spcAft>
+                <a:spcPts val="1400"/>
+              </a:spcAft>
+            </a:pPr>
             <a:r>
               <a:rPr sz="1900" b="0">
                 <a:solidFill>
@@ -4495,7 +4587,11 @@
           </a:bodyPr>
           <a:lstStyle/>
           <a:p>
-            <a:pPr algn="l"/>
+            <a:pPr algn="l">
+              <a:spcAft>
+                <a:spcPts val="1400"/>
+              </a:spcAft>
+            </a:pPr>
             <a:r>
               <a:rPr sz="1900" b="0">
                 <a:solidFill>
@@ -4507,7 +4603,11 @@
             </a:r>
           </a:p>
           <a:p>
-            <a:pPr algn="l"/>
+            <a:pPr algn="l">
+              <a:spcAft>
+                <a:spcPts val="1400"/>
+              </a:spcAft>
+            </a:pPr>
             <a:r>
               <a:rPr sz="1900" b="0">
                 <a:solidFill>
@@ -4519,7 +4619,11 @@
             </a:r>
           </a:p>
           <a:p>
-            <a:pPr lvl="1" algn="l"/>
+            <a:pPr lvl="1" algn="l">
+              <a:spcAft>
+                <a:spcPts val="1400"/>
+              </a:spcAft>
+            </a:pPr>
             <a:r>
               <a:rPr sz="1900" b="0">
                 <a:solidFill>
@@ -4531,7 +4635,11 @@
             </a:r>
           </a:p>
           <a:p>
-            <a:pPr algn="l"/>
+            <a:pPr algn="l">
+              <a:spcAft>
+                <a:spcPts val="1400"/>
+              </a:spcAft>
+            </a:pPr>
             <a:r>
               <a:rPr sz="1900" b="0">
                 <a:solidFill>
@@ -4697,7 +4805,11 @@
           </a:bodyPr>
           <a:lstStyle/>
           <a:p>
-            <a:pPr algn="l"/>
+            <a:pPr algn="l">
+              <a:spcAft>
+                <a:spcPts val="1400"/>
+              </a:spcAft>
+            </a:pPr>
             <a:r>
               <a:rPr sz="1900" b="0">
                 <a:solidFill>
@@ -4709,7 +4821,11 @@
             </a:r>
           </a:p>
           <a:p>
-            <a:pPr lvl="1" algn="l"/>
+            <a:pPr lvl="1" algn="l">
+              <a:spcAft>
+                <a:spcPts val="1400"/>
+              </a:spcAft>
+            </a:pPr>
             <a:r>
               <a:rPr sz="1900" b="0">
                 <a:solidFill>
@@ -4721,7 +4837,11 @@
             </a:r>
           </a:p>
           <a:p>
-            <a:pPr lvl="1" algn="l"/>
+            <a:pPr lvl="1" algn="l">
+              <a:spcAft>
+                <a:spcPts val="1400"/>
+              </a:spcAft>
+            </a:pPr>
             <a:r>
               <a:rPr sz="1900" b="0">
                 <a:solidFill>
@@ -4733,7 +4853,11 @@
             </a:r>
           </a:p>
           <a:p>
-            <a:pPr algn="l"/>
+            <a:pPr algn="l">
+              <a:spcAft>
+                <a:spcPts val="1400"/>
+              </a:spcAft>
+            </a:pPr>
             <a:r>
               <a:rPr sz="1900" b="0">
                 <a:solidFill>
@@ -4745,7 +4869,11 @@
             </a:r>
           </a:p>
           <a:p>
-            <a:pPr algn="l"/>
+            <a:pPr algn="l">
+              <a:spcAft>
+                <a:spcPts val="1400"/>
+              </a:spcAft>
+            </a:pPr>
             <a:r>
               <a:rPr sz="1900" b="0">
                 <a:solidFill>
@@ -4911,7 +5039,11 @@
           </a:bodyPr>
           <a:lstStyle/>
           <a:p>
-            <a:pPr algn="l"/>
+            <a:pPr algn="l">
+              <a:spcAft>
+                <a:spcPts val="1400"/>
+              </a:spcAft>
+            </a:pPr>
             <a:r>
               <a:rPr sz="1900" b="0">
                 <a:solidFill>
@@ -4923,7 +5055,11 @@
             </a:r>
           </a:p>
           <a:p>
-            <a:pPr algn="l"/>
+            <a:pPr algn="l">
+              <a:spcAft>
+                <a:spcPts val="1400"/>
+              </a:spcAft>
+            </a:pPr>
             <a:r>
               <a:rPr sz="1900" b="0">
                 <a:solidFill>
@@ -4935,7 +5071,11 @@
             </a:r>
           </a:p>
           <a:p>
-            <a:pPr algn="l"/>
+            <a:pPr algn="l">
+              <a:spcAft>
+                <a:spcPts val="1400"/>
+              </a:spcAft>
+            </a:pPr>
             <a:r>
               <a:rPr sz="1900" b="0">
                 <a:solidFill>
@@ -4947,7 +5087,11 @@
             </a:r>
           </a:p>
           <a:p>
-            <a:pPr algn="l"/>
+            <a:pPr algn="l">
+              <a:spcAft>
+                <a:spcPts val="1400"/>
+              </a:spcAft>
+            </a:pPr>
             <a:r>
               <a:rPr sz="1900" b="0">
                 <a:solidFill>
@@ -5148,7 +5292,11 @@
           </a:bodyPr>
           <a:lstStyle/>
           <a:p>
-            <a:pPr algn="l"/>
+            <a:pPr algn="l">
+              <a:spcAft>
+                <a:spcPts val="1400"/>
+              </a:spcAft>
+            </a:pPr>
             <a:r>
               <a:rPr sz="1900" b="0">
                 <a:solidFill>
@@ -5160,7 +5308,11 @@
             </a:r>
           </a:p>
           <a:p>
-            <a:pPr algn="l"/>
+            <a:pPr algn="l">
+              <a:spcAft>
+                <a:spcPts val="1400"/>
+              </a:spcAft>
+            </a:pPr>
             <a:r>
               <a:rPr sz="1900" b="0">
                 <a:solidFill>
@@ -5172,7 +5324,11 @@
             </a:r>
           </a:p>
           <a:p>
-            <a:pPr algn="l"/>
+            <a:pPr algn="l">
+              <a:spcAft>
+                <a:spcPts val="1400"/>
+              </a:spcAft>
+            </a:pPr>
             <a:r>
               <a:rPr sz="1900" b="0">
                 <a:solidFill>
@@ -5184,7 +5340,11 @@
             </a:r>
           </a:p>
           <a:p>
-            <a:pPr algn="l"/>
+            <a:pPr algn="l">
+              <a:spcAft>
+                <a:spcPts val="1400"/>
+              </a:spcAft>
+            </a:pPr>
             <a:r>
               <a:rPr sz="1900" b="0">
                 <a:solidFill>

</xml_diff>

<commit_message>
auto: make_slides.py 編集前 (2026-06-07 16:51)
</commit_message>
<xml_diff>
--- a/slides/llcore_findings_2026_en.pptx
+++ b/slides/llcore_findings_2026_en.pptx
@@ -114,6 +114,696 @@
     </a:lvl9pPr>
   </p:defaultTextStyle>
 </p:presentation>
+</file>
+
+<file path=ppt/charts/chart1.xml><?xml version="1.0" encoding="utf-8"?>
+<c:chartSpace xmlns:c="http://schemas.openxmlformats.org/drawingml/2006/chart" xmlns:a="http://schemas.openxmlformats.org/drawingml/2006/main" xmlns:r="http://schemas.openxmlformats.org/officeDocument/2006/relationships">
+  <c:date1904 val="0"/>
+  <c:chart>
+    <c:autoTitleDeleted val="1"/>
+    <c:plotArea>
+      <c:barChart>
+        <c:barDir val="col"/>
+        <c:grouping val="clustered"/>
+        <c:ser>
+          <c:idx val="0"/>
+          <c:order val="0"/>
+          <c:tx>
+            <c:strRef>
+              <c:f>Sheet1!$B$1</c:f>
+              <c:strCache>
+                <c:ptCount val="1"/>
+                <c:pt idx="0">
+                  <c:v>v</c:v>
+                </c:pt>
+              </c:strCache>
+            </c:strRef>
+          </c:tx>
+          <c:dPt>
+            <c:idx val="0"/>
+            <c:spPr>
+              <a:solidFill>
+                <a:srgbClr val="7F7F7F"/>
+              </a:solidFill>
+            </c:spPr>
+          </c:dPt>
+          <c:dPt>
+            <c:idx val="1"/>
+            <c:spPr>
+              <a:solidFill>
+                <a:srgbClr val="E8A33D"/>
+              </a:solidFill>
+            </c:spPr>
+          </c:dPt>
+          <c:dPt>
+            <c:idx val="2"/>
+            <c:spPr>
+              <a:solidFill>
+                <a:srgbClr val="D99694"/>
+              </a:solidFill>
+            </c:spPr>
+          </c:dPt>
+          <c:dPt>
+            <c:idx val="3"/>
+            <c:spPr>
+              <a:solidFill>
+                <a:srgbClr val="4F81BD"/>
+              </a:solidFill>
+            </c:spPr>
+          </c:dPt>
+          <c:cat>
+            <c:strRef>
+              <c:f>Sheet1!$A$2:$A$5</c:f>
+              <c:strCache>
+                <c:ptCount val="4"/>
+                <c:pt idx="0">
+                  <c:v>NONE
+no gate</c:v>
+                </c:pt>
+                <c:pt idx="1">
+                  <c:v>OBSERVE
+observational</c:v>
+                </c:pt>
+                <c:pt idx="2">
+                  <c:v>EXO
+frozen gate</c:v>
+                </c:pt>
+                <c:pt idx="3">
+                  <c:v>ENDO
+proof</c:v>
+                </c:pt>
+              </c:strCache>
+            </c:strRef>
+          </c:cat>
+          <c:val>
+            <c:numRef>
+              <c:f>Sheet1!$B$2:$B$5</c:f>
+              <c:numCache>
+                <c:formatCode>General</c:formatCode>
+                <c:ptCount val="4"/>
+                <c:pt idx="0">
+                  <c:v>27.2</c:v>
+                </c:pt>
+                <c:pt idx="1">
+                  <c:v>17.3</c:v>
+                </c:pt>
+                <c:pt idx="2">
+                  <c:v>10.2</c:v>
+                </c:pt>
+                <c:pt idx="3">
+                  <c:v>0.0</c:v>
+                </c:pt>
+              </c:numCache>
+            </c:numRef>
+          </c:val>
+        </c:ser>
+        <c:dLbls>
+          <c:numFmt formatCode="0.0" sourceLinked="0"/>
+          <c:txPr>
+            <a:bodyPr/>
+            <a:lstStyle/>
+            <a:p>
+              <a:pPr>
+                <a:defRPr sz="1100" b="1"/>
+              </a:pPr>
+            </a:p>
+          </c:txPr>
+          <c:showLegendKey val="0"/>
+          <c:showVal val="1"/>
+          <c:showCatName val="0"/>
+          <c:showSerName val="0"/>
+          <c:showPercent val="0"/>
+          <c:showBubbleSize val="0"/>
+          <c:showLeaderLines val="1"/>
+        </c:dLbls>
+        <c:gapWidth val="60"/>
+        <c:axId val="-2068027336"/>
+        <c:axId val="-2113994440"/>
+      </c:barChart>
+      <c:catAx>
+        <c:axId val="-2068027336"/>
+        <c:scaling>
+          <c:orientation val="minMax"/>
+        </c:scaling>
+        <c:delete val="0"/>
+        <c:axPos val="b"/>
+        <c:majorTickMark val="out"/>
+        <c:minorTickMark val="none"/>
+        <c:tickLblPos val="nextTo"/>
+        <c:spPr>
+          <a:ln>
+            <a:solidFill>
+              <a:srgbClr val="666666"/>
+            </a:solidFill>
+          </a:ln>
+        </c:spPr>
+        <c:crossAx val="-2113994440"/>
+        <c:crosses val="autoZero"/>
+        <c:auto val="1"/>
+        <c:lblAlgn val="ctr"/>
+        <c:lblOffset val="100"/>
+        <c:noMultiLvlLbl val="0"/>
+      </c:catAx>
+      <c:valAx>
+        <c:axId val="-2113994440"/>
+        <c:scaling/>
+        <c:delete/>
+        <c:axPos val="l"/>
+        <c:majorTickMark val="out"/>
+        <c:minorTickMark val="none"/>
+        <c:tickLblPos val="nextTo"/>
+        <c:crossAx val="-2068027336"/>
+        <c:crosses val="autoZero"/>
+      </c:valAx>
+    </c:plotArea>
+    <c:dispBlanksAs val="gap"/>
+  </c:chart>
+  <c:txPr>
+    <a:bodyPr/>
+    <a:lstStyle/>
+    <a:p>
+      <a:pPr>
+        <a:defRPr sz="1100">
+          <a:latin typeface="Meiryo UI"/>
+        </a:defRPr>
+      </a:pPr>
+      <a:endParaRPr lang="en-US"/>
+    </a:p>
+  </c:txPr>
+  <c:externalData r:id="rId1">
+    <c:autoUpdate val="0"/>
+  </c:externalData>
+</c:chartSpace>
+</file>
+
+<file path=ppt/charts/chart2.xml><?xml version="1.0" encoding="utf-8"?>
+<c:chartSpace xmlns:c="http://schemas.openxmlformats.org/drawingml/2006/chart" xmlns:a="http://schemas.openxmlformats.org/drawingml/2006/main" xmlns:r="http://schemas.openxmlformats.org/officeDocument/2006/relationships">
+  <c:date1904 val="0"/>
+  <c:chart>
+    <c:autoTitleDeleted val="1"/>
+    <c:plotArea>
+      <c:barChart>
+        <c:barDir val="col"/>
+        <c:grouping val="clustered"/>
+        <c:ser>
+          <c:idx val="0"/>
+          <c:order val="0"/>
+          <c:tx>
+            <c:strRef>
+              <c:f>Sheet1!$B$1</c:f>
+              <c:strCache>
+                <c:ptCount val="1"/>
+                <c:pt idx="0">
+                  <c:v>v</c:v>
+                </c:pt>
+              </c:strCache>
+            </c:strRef>
+          </c:tx>
+          <c:dPt>
+            <c:idx val="0"/>
+            <c:spPr>
+              <a:solidFill>
+                <a:srgbClr val="7F7F7F"/>
+              </a:solidFill>
+            </c:spPr>
+          </c:dPt>
+          <c:dPt>
+            <c:idx val="1"/>
+            <c:spPr>
+              <a:solidFill>
+                <a:srgbClr val="8064A2"/>
+              </a:solidFill>
+            </c:spPr>
+          </c:dPt>
+          <c:dPt>
+            <c:idx val="2"/>
+            <c:spPr>
+              <a:solidFill>
+                <a:srgbClr val="4F81BD"/>
+              </a:solidFill>
+            </c:spPr>
+          </c:dPt>
+          <c:cat>
+            <c:strRef>
+              <c:f>Sheet1!$A$2:$A$4</c:f>
+              <c:strCache>
+                <c:ptCount val="3"/>
+                <c:pt idx="0">
+                  <c:v>NONE
+death = erasure</c:v>
+                </c:pt>
+                <c:pt idx="1">
+                  <c:v>REVIVE
+die → revive</c:v>
+                </c:pt>
+                <c:pt idx="2">
+                  <c:v>ENDO
+proof</c:v>
+                </c:pt>
+              </c:strCache>
+            </c:strRef>
+          </c:cat>
+          <c:val>
+            <c:numRef>
+              <c:f>Sheet1!$B$2:$B$4</c:f>
+              <c:numCache>
+                <c:formatCode>General</c:formatCode>
+                <c:ptCount val="3"/>
+                <c:pt idx="0">
+                  <c:v>0.649</c:v>
+                </c:pt>
+                <c:pt idx="1">
+                  <c:v>0.708</c:v>
+                </c:pt>
+                <c:pt idx="2">
+                  <c:v>0.75</c:v>
+                </c:pt>
+              </c:numCache>
+            </c:numRef>
+          </c:val>
+        </c:ser>
+        <c:dLbls>
+          <c:numFmt formatCode="0.000" sourceLinked="0"/>
+          <c:txPr>
+            <a:bodyPr/>
+            <a:lstStyle/>
+            <a:p>
+              <a:pPr>
+                <a:defRPr sz="1100" b="1"/>
+              </a:pPr>
+            </a:p>
+          </c:txPr>
+          <c:showLegendKey val="0"/>
+          <c:showVal val="1"/>
+          <c:showCatName val="0"/>
+          <c:showSerName val="0"/>
+          <c:showPercent val="0"/>
+          <c:showBubbleSize val="0"/>
+          <c:showLeaderLines val="1"/>
+        </c:dLbls>
+        <c:gapWidth val="60"/>
+        <c:axId val="-2068027336"/>
+        <c:axId val="-2113994440"/>
+      </c:barChart>
+      <c:catAx>
+        <c:axId val="-2068027336"/>
+        <c:scaling>
+          <c:orientation val="minMax"/>
+        </c:scaling>
+        <c:delete val="0"/>
+        <c:axPos val="b"/>
+        <c:majorTickMark val="out"/>
+        <c:minorTickMark val="none"/>
+        <c:tickLblPos val="nextTo"/>
+        <c:spPr>
+          <a:ln>
+            <a:solidFill>
+              <a:srgbClr val="666666"/>
+            </a:solidFill>
+          </a:ln>
+        </c:spPr>
+        <c:crossAx val="-2113994440"/>
+        <c:crosses val="autoZero"/>
+        <c:auto val="1"/>
+        <c:lblAlgn val="ctr"/>
+        <c:lblOffset val="100"/>
+        <c:noMultiLvlLbl val="0"/>
+      </c:catAx>
+      <c:valAx>
+        <c:axId val="-2113994440"/>
+        <c:scaling>
+          <c:max val="0.78"/>
+          <c:min val="0.6"/>
+        </c:scaling>
+        <c:delete/>
+        <c:axPos val="l"/>
+        <c:majorTickMark val="out"/>
+        <c:minorTickMark val="none"/>
+        <c:tickLblPos val="nextTo"/>
+        <c:crossAx val="-2068027336"/>
+        <c:crosses val="autoZero"/>
+      </c:valAx>
+    </c:plotArea>
+    <c:dispBlanksAs val="gap"/>
+  </c:chart>
+  <c:txPr>
+    <a:bodyPr/>
+    <a:lstStyle/>
+    <a:p>
+      <a:pPr>
+        <a:defRPr sz="1100">
+          <a:latin typeface="Meiryo UI"/>
+        </a:defRPr>
+      </a:pPr>
+      <a:endParaRPr lang="en-US"/>
+    </a:p>
+  </c:txPr>
+  <c:externalData r:id="rId1">
+    <c:autoUpdate val="0"/>
+  </c:externalData>
+</c:chartSpace>
+</file>
+
+<file path=ppt/charts/chart3.xml><?xml version="1.0" encoding="utf-8"?>
+<c:chartSpace xmlns:c="http://schemas.openxmlformats.org/drawingml/2006/chart" xmlns:a="http://schemas.openxmlformats.org/drawingml/2006/main" xmlns:r="http://schemas.openxmlformats.org/officeDocument/2006/relationships">
+  <c:date1904 val="0"/>
+  <c:chart>
+    <c:autoTitleDeleted val="1"/>
+    <c:plotArea>
+      <c:barChart>
+        <c:barDir val="col"/>
+        <c:grouping val="clustered"/>
+        <c:ser>
+          <c:idx val="0"/>
+          <c:order val="0"/>
+          <c:tx>
+            <c:strRef>
+              <c:f>Sheet1!$B$1</c:f>
+              <c:strCache>
+                <c:ptCount val="1"/>
+                <c:pt idx="0">
+                  <c:v>v</c:v>
+                </c:pt>
+              </c:strCache>
+            </c:strRef>
+          </c:tx>
+          <c:dPt>
+            <c:idx val="0"/>
+            <c:spPr>
+              <a:solidFill>
+                <a:srgbClr val="7F7F7F"/>
+              </a:solidFill>
+            </c:spPr>
+          </c:dPt>
+          <c:dPt>
+            <c:idx val="1"/>
+            <c:spPr>
+              <a:solidFill>
+                <a:srgbClr val="E8A33D"/>
+              </a:solidFill>
+            </c:spPr>
+          </c:dPt>
+          <c:dPt>
+            <c:idx val="2"/>
+            <c:spPr>
+              <a:solidFill>
+                <a:srgbClr val="8064A2"/>
+              </a:solidFill>
+            </c:spPr>
+          </c:dPt>
+          <c:dPt>
+            <c:idx val="3"/>
+            <c:spPr>
+              <a:solidFill>
+                <a:srgbClr val="9BBB59"/>
+              </a:solidFill>
+            </c:spPr>
+          </c:dPt>
+          <c:dPt>
+            <c:idx val="4"/>
+            <c:spPr>
+              <a:solidFill>
+                <a:srgbClr val="4F81BD"/>
+              </a:solidFill>
+            </c:spPr>
+          </c:dPt>
+          <c:cat>
+            <c:strRef>
+              <c:f>Sheet1!$A$2:$A$6</c:f>
+              <c:strCache>
+                <c:ptCount val="5"/>
+                <c:pt idx="0">
+                  <c:v>NONE</c:v>
+                </c:pt>
+                <c:pt idx="1">
+                  <c:v>O</c:v>
+                </c:pt>
+                <c:pt idx="2">
+                  <c:v>R</c:v>
+                </c:pt>
+                <c:pt idx="3">
+                  <c:v>R+O</c:v>
+                </c:pt>
+                <c:pt idx="4">
+                  <c:v>all 4 E-combos</c:v>
+                </c:pt>
+              </c:strCache>
+            </c:strRef>
+          </c:cat>
+          <c:val>
+            <c:numRef>
+              <c:f>Sheet1!$B$2:$B$6</c:f>
+              <c:numCache>
+                <c:formatCode>General</c:formatCode>
+                <c:ptCount val="5"/>
+                <c:pt idx="0">
+                  <c:v>27.2</c:v>
+                </c:pt>
+                <c:pt idx="1">
+                  <c:v>17.3</c:v>
+                </c:pt>
+                <c:pt idx="2">
+                  <c:v>18.8</c:v>
+                </c:pt>
+                <c:pt idx="3">
+                  <c:v>6.2</c:v>
+                </c:pt>
+                <c:pt idx="4">
+                  <c:v>0.0</c:v>
+                </c:pt>
+              </c:numCache>
+            </c:numRef>
+          </c:val>
+        </c:ser>
+        <c:dLbls>
+          <c:numFmt formatCode="0.0" sourceLinked="0"/>
+          <c:txPr>
+            <a:bodyPr/>
+            <a:lstStyle/>
+            <a:p>
+              <a:pPr>
+                <a:defRPr sz="1100" b="1"/>
+              </a:pPr>
+            </a:p>
+          </c:txPr>
+          <c:showLegendKey val="0"/>
+          <c:showVal val="1"/>
+          <c:showCatName val="0"/>
+          <c:showSerName val="0"/>
+          <c:showPercent val="0"/>
+          <c:showBubbleSize val="0"/>
+          <c:showLeaderLines val="1"/>
+        </c:dLbls>
+        <c:gapWidth val="60"/>
+        <c:axId val="-2068027336"/>
+        <c:axId val="-2113994440"/>
+      </c:barChart>
+      <c:catAx>
+        <c:axId val="-2068027336"/>
+        <c:scaling>
+          <c:orientation val="minMax"/>
+        </c:scaling>
+        <c:delete val="0"/>
+        <c:axPos val="b"/>
+        <c:majorTickMark val="out"/>
+        <c:minorTickMark val="none"/>
+        <c:tickLblPos val="nextTo"/>
+        <c:spPr>
+          <a:ln>
+            <a:solidFill>
+              <a:srgbClr val="666666"/>
+            </a:solidFill>
+          </a:ln>
+        </c:spPr>
+        <c:crossAx val="-2113994440"/>
+        <c:crosses val="autoZero"/>
+        <c:auto val="1"/>
+        <c:lblAlgn val="ctr"/>
+        <c:lblOffset val="100"/>
+        <c:noMultiLvlLbl val="0"/>
+      </c:catAx>
+      <c:valAx>
+        <c:axId val="-2113994440"/>
+        <c:scaling/>
+        <c:delete/>
+        <c:axPos val="l"/>
+        <c:majorTickMark val="out"/>
+        <c:minorTickMark val="none"/>
+        <c:tickLblPos val="nextTo"/>
+        <c:crossAx val="-2068027336"/>
+        <c:crosses val="autoZero"/>
+      </c:valAx>
+    </c:plotArea>
+    <c:dispBlanksAs val="gap"/>
+  </c:chart>
+  <c:txPr>
+    <a:bodyPr/>
+    <a:lstStyle/>
+    <a:p>
+      <a:pPr>
+        <a:defRPr sz="1100">
+          <a:latin typeface="Meiryo UI"/>
+        </a:defRPr>
+      </a:pPr>
+      <a:endParaRPr lang="en-US"/>
+    </a:p>
+  </c:txPr>
+  <c:externalData r:id="rId1">
+    <c:autoUpdate val="0"/>
+  </c:externalData>
+</c:chartSpace>
+</file>
+
+<file path=ppt/charts/chart4.xml><?xml version="1.0" encoding="utf-8"?>
+<c:chartSpace xmlns:c="http://schemas.openxmlformats.org/drawingml/2006/chart" xmlns:a="http://schemas.openxmlformats.org/drawingml/2006/main" xmlns:r="http://schemas.openxmlformats.org/officeDocument/2006/relationships">
+  <c:date1904 val="0"/>
+  <c:chart>
+    <c:autoTitleDeleted val="1"/>
+    <c:plotArea>
+      <c:barChart>
+        <c:barDir val="col"/>
+        <c:grouping val="clustered"/>
+        <c:ser>
+          <c:idx val="0"/>
+          <c:order val="0"/>
+          <c:tx>
+            <c:strRef>
+              <c:f>Sheet1!$B$1</c:f>
+              <c:strCache>
+                <c:ptCount val="1"/>
+                <c:pt idx="0">
+                  <c:v>v</c:v>
+                </c:pt>
+              </c:strCache>
+            </c:strRef>
+          </c:tx>
+          <c:dPt>
+            <c:idx val="0"/>
+            <c:spPr>
+              <a:solidFill>
+                <a:srgbClr val="9BBB59"/>
+              </a:solidFill>
+            </c:spPr>
+          </c:dPt>
+          <c:dPt>
+            <c:idx val="1"/>
+            <c:spPr>
+              <a:solidFill>
+                <a:srgbClr val="D99694"/>
+              </a:solidFill>
+            </c:spPr>
+          </c:dPt>
+          <c:cat>
+            <c:strRef>
+              <c:f>Sheet1!$A$2:$A$3</c:f>
+              <c:strCache>
+                <c:ptCount val="2"/>
+                <c:pt idx="0">
+                  <c:v>GOOD blocks
+(premise holds)</c:v>
+                </c:pt>
+                <c:pt idx="1">
+                  <c:v>BAD blocks
+(premise broken)</c:v>
+                </c:pt>
+              </c:strCache>
+            </c:strRef>
+          </c:cat>
+          <c:val>
+            <c:numRef>
+              <c:f>Sheet1!$B$2:$B$3</c:f>
+              <c:numCache>
+                <c:formatCode>General</c:formatCode>
+                <c:ptCount val="2"/>
+                <c:pt idx="0">
+                  <c:v>0.91</c:v>
+                </c:pt>
+                <c:pt idx="1">
+                  <c:v>0.51</c:v>
+                </c:pt>
+              </c:numCache>
+            </c:numRef>
+          </c:val>
+        </c:ser>
+        <c:dLbls>
+          <c:numFmt formatCode="0.00" sourceLinked="0"/>
+          <c:txPr>
+            <a:bodyPr/>
+            <a:lstStyle/>
+            <a:p>
+              <a:pPr>
+                <a:defRPr sz="1100" b="1"/>
+              </a:pPr>
+            </a:p>
+          </c:txPr>
+          <c:showLegendKey val="0"/>
+          <c:showVal val="1"/>
+          <c:showCatName val="0"/>
+          <c:showSerName val="0"/>
+          <c:showPercent val="0"/>
+          <c:showBubbleSize val="0"/>
+          <c:showLeaderLines val="1"/>
+        </c:dLbls>
+        <c:gapWidth val="60"/>
+        <c:axId val="-2068027336"/>
+        <c:axId val="-2113994440"/>
+      </c:barChart>
+      <c:catAx>
+        <c:axId val="-2068027336"/>
+        <c:scaling>
+          <c:orientation val="minMax"/>
+        </c:scaling>
+        <c:delete val="0"/>
+        <c:axPos val="b"/>
+        <c:majorTickMark val="out"/>
+        <c:minorTickMark val="none"/>
+        <c:tickLblPos val="nextTo"/>
+        <c:spPr>
+          <a:ln>
+            <a:solidFill>
+              <a:srgbClr val="666666"/>
+            </a:solidFill>
+          </a:ln>
+        </c:spPr>
+        <c:crossAx val="-2113994440"/>
+        <c:crosses val="autoZero"/>
+        <c:auto val="1"/>
+        <c:lblAlgn val="ctr"/>
+        <c:lblOffset val="100"/>
+        <c:noMultiLvlLbl val="0"/>
+      </c:catAx>
+      <c:valAx>
+        <c:axId val="-2113994440"/>
+        <c:scaling>
+          <c:max val="1.0"/>
+        </c:scaling>
+        <c:delete/>
+        <c:axPos val="l"/>
+        <c:majorTickMark val="out"/>
+        <c:minorTickMark val="none"/>
+        <c:tickLblPos val="nextTo"/>
+        <c:crossAx val="-2068027336"/>
+        <c:crosses val="autoZero"/>
+      </c:valAx>
+    </c:plotArea>
+    <c:dispBlanksAs val="gap"/>
+  </c:chart>
+  <c:txPr>
+    <a:bodyPr/>
+    <a:lstStyle/>
+    <a:p>
+      <a:pPr>
+        <a:defRPr sz="1100">
+          <a:latin typeface="Meiryo UI"/>
+        </a:defRPr>
+      </a:pPr>
+      <a:endParaRPr lang="en-US"/>
+    </a:p>
+  </c:txPr>
+  <c:externalData r:id="rId1">
+    <c:autoUpdate val="0"/>
+  </c:externalData>
+</c:chartSpace>
 </file>
 
 <file path=ppt/slideLayouts/slideLayout1.xml><?xml version="1.0" encoding="utf-8"?>
@@ -3099,13 +3789,56 @@
       <p:grpSpPr/>
       <p:sp>
         <p:nvSpPr>
-          <p:cNvPr id="2" name="TextBox 1"/>
+          <p:cNvPr id="2" name="Rectangle 1"/>
+          <p:cNvSpPr/>
+          <p:nvPr/>
+        </p:nvSpPr>
+        <p:spPr>
+          <a:xfrm>
+            <a:off x="0" y="6035040"/>
+            <a:ext cx="12191695" cy="164592"/>
+          </a:xfrm>
+          <a:prstGeom prst="rect">
+            <a:avLst/>
+          </a:prstGeom>
+          <a:solidFill>
+            <a:srgbClr val="4F81BD"/>
+          </a:solidFill>
+          <a:ln>
+            <a:noFill/>
+          </a:ln>
+        </p:spPr>
+        <p:style>
+          <a:lnRef idx="1">
+            <a:schemeClr val="accent1"/>
+          </a:lnRef>
+          <a:fillRef idx="3">
+            <a:schemeClr val="accent1"/>
+          </a:fillRef>
+          <a:effectRef idx="2">
+            <a:schemeClr val="accent1"/>
+          </a:effectRef>
+          <a:fontRef idx="minor">
+            <a:schemeClr val="lt1"/>
+          </a:fontRef>
+        </p:style>
+        <p:txBody>
+          <a:bodyPr rtlCol="0" anchor="ctr"/>
+          <a:lstStyle/>
+          <a:p>
+            <a:pPr algn="ctr"/>
+          </a:p>
+        </p:txBody>
+      </p:sp>
+      <p:sp>
+        <p:nvSpPr>
+          <p:cNvPr id="3" name="TextBox 2"/>
           <p:cNvSpPr txBox="1"/>
           <p:nvPr/>
         </p:nvSpPr>
         <p:spPr>
           <a:xfrm>
-            <a:off x="1097280" y="2011680"/>
+            <a:off x="1097280" y="1828800"/>
             <a:ext cx="10058400" cy="1280160"/>
           </a:xfrm>
           <a:prstGeom prst="rect">
@@ -3134,13 +3867,13 @@
       </p:sp>
       <p:sp>
         <p:nvSpPr>
-          <p:cNvPr id="3" name="TextBox 2"/>
+          <p:cNvPr id="4" name="TextBox 3"/>
           <p:cNvSpPr txBox="1"/>
           <p:nvPr/>
         </p:nvSpPr>
         <p:spPr>
           <a:xfrm>
-            <a:off x="1097280" y="3291840"/>
+            <a:off x="1097280" y="3108960"/>
             <a:ext cx="10058400" cy="731520"/>
           </a:xfrm>
           <a:prstGeom prst="rect">
@@ -3169,13 +3902,13 @@
       </p:sp>
       <p:sp>
         <p:nvSpPr>
-          <p:cNvPr id="4" name="TextBox 3"/>
+          <p:cNvPr id="5" name="TextBox 4"/>
           <p:cNvSpPr txBox="1"/>
           <p:nvPr/>
         </p:nvSpPr>
         <p:spPr>
           <a:xfrm>
-            <a:off x="1097280" y="4754880"/>
+            <a:off x="1097280" y="4480560"/>
             <a:ext cx="10058400" cy="1097280"/>
           </a:xfrm>
           <a:prstGeom prst="rect">
@@ -3228,7 +3961,7 @@
       </p:sp>
       <p:sp>
         <p:nvSpPr>
-          <p:cNvPr id="5" name="TextBox 4"/>
+          <p:cNvPr id="6" name="TextBox 5"/>
           <p:cNvSpPr txBox="1"/>
           <p:nvPr/>
         </p:nvSpPr>
@@ -3346,7 +4079,7 @@
           <a:p>
             <a:pPr algn="l"/>
             <a:r>
-              <a:rPr sz="3000" b="1">
+              <a:rPr sz="2900" b="1">
                 <a:solidFill>
                   <a:srgbClr val="1A1A1A"/>
                 </a:solidFill>
@@ -3366,7 +4099,7 @@
         <p:spPr>
           <a:xfrm>
             <a:off x="822960" y="1554480"/>
-            <a:ext cx="10607040" cy="4206240"/>
+            <a:ext cx="6035040" cy="4297680"/>
           </a:xfrm>
           <a:prstGeom prst="rect">
             <a:avLst/>
@@ -3381,81 +4114,65 @@
           <a:p>
             <a:pPr algn="l">
               <a:spcAft>
-                <a:spcPts val="1400"/>
+                <a:spcPts val="1200"/>
               </a:spcAft>
             </a:pPr>
             <a:r>
-              <a:rPr sz="1900" b="0">
+              <a:rPr sz="1700" b="0">
                 <a:solidFill>
                   <a:srgbClr val="1A1A1A"/>
                 </a:solidFill>
                 <a:latin typeface="Meiryo UI"/>
               </a:rPr>
-              <a:t>These slides: CC BY 4.0 — free for corporate training, tech scouting, product evaluation with attribution</a:t>
+              <a:t>These slides: CC BY 4.0 — corporate training, tech scouting, product evaluation OK with attribution</a:t>
             </a:r>
           </a:p>
           <a:p>
             <a:pPr algn="l">
               <a:spcAft>
-                <a:spcPts val="1400"/>
+                <a:spcPts val="1200"/>
               </a:spcAft>
             </a:pPr>
             <a:r>
-              <a:rPr sz="1900" b="0">
+              <a:rPr sz="1700" b="0">
                 <a:solidFill>
                   <a:srgbClr val="1A1A1A"/>
                 </a:solidFill>
                 <a:latin typeface="Meiryo UI"/>
               </a:rPr>
-              <a:t>Code / paper draft: Apache-2.0 + Commercial dual license (github.com/furuse-kazufumi/llcore)</a:t>
+              <a:t>Code / paper draft: Apache-2.0 + Commercial dual license</a:t>
             </a:r>
           </a:p>
           <a:p>
             <a:pPr algn="l">
               <a:spcAft>
-                <a:spcPts val="1400"/>
+                <a:spcPts val="1200"/>
               </a:spcAft>
             </a:pPr>
             <a:r>
-              <a:rPr sz="1900" b="0">
+              <a:rPr sz="1700" b="0">
                 <a:solidFill>
                   <a:srgbClr val="1A1A1A"/>
                 </a:solidFill>
                 <a:latin typeface="Meiryo UI"/>
               </a:rPr>
-              <a:t>Closed-source integration, SLA, NDA consulting = commercial licensing: kazufumi@furuse.work</a:t>
+              <a:t>Closed-source integration / SLA / NDA consulting: kazufumi@furuse.work</a:t>
             </a:r>
           </a:p>
           <a:p>
             <a:pPr algn="l">
               <a:spcAft>
-                <a:spcPts val="1400"/>
+                <a:spcPts val="1200"/>
               </a:spcAft>
             </a:pPr>
             <a:r>
-              <a:rPr sz="1900" b="0">
+              <a:rPr sz="1700" b="0">
                 <a:solidFill>
                   <a:srgbClr val="1A1A1A"/>
                 </a:solidFill>
                 <a:latin typeface="Meiryo UI"/>
               </a:rPr>
-              <a:t>Articles (Japanese): qiita.com/furuse-kazufumi</a:t>
-            </a:r>
-          </a:p>
-          <a:p>
-            <a:pPr algn="l">
-              <a:spcAft>
-                <a:spcPts val="1400"/>
-              </a:spcAft>
-            </a:pPr>
-            <a:r>
-              <a:rPr sz="1900" b="0">
-                <a:solidFill>
-                  <a:srgbClr val="1A1A1A"/>
-                </a:solidFill>
-                <a:latin typeface="Meiryo UI"/>
-              </a:rPr>
-              <a:t>Attribution example: "Kazufumi Furuse, llcore (2026), github.com/furuse-kazufumi/llcore"</a:t>
+              <a:t>Attribution: "Kazufumi Furuse, llcore (2026), github.com/furuse-kazufumi/llcore"</a:t>
             </a:r>
           </a:p>
         </p:txBody>
@@ -3491,6 +4208,172 @@
                 <a:latin typeface="Meiryo UI"/>
               </a:rPr>
               <a:t>© 2026 Kazufumi Furuse — CC BY 4.0 | Source: github.com/furuse-kazufumi/llcore | qiita.com/furuse-kazufumi</a:t>
+            </a:r>
+          </a:p>
+        </p:txBody>
+      </p:sp>
+      <p:sp>
+        <p:nvSpPr>
+          <p:cNvPr id="6" name="Rounded Rectangle 5"/>
+          <p:cNvSpPr/>
+          <p:nvPr/>
+        </p:nvSpPr>
+        <p:spPr>
+          <a:xfrm>
+            <a:off x="7040880" y="2011680"/>
+            <a:ext cx="4206240" cy="822960"/>
+          </a:xfrm>
+          <a:prstGeom prst="roundRect">
+            <a:avLst/>
+          </a:prstGeom>
+          <a:solidFill>
+            <a:srgbClr val="4F81BD"/>
+          </a:solidFill>
+          <a:ln>
+            <a:noFill/>
+          </a:ln>
+        </p:spPr>
+        <p:style>
+          <a:lnRef idx="1">
+            <a:schemeClr val="accent1"/>
+          </a:lnRef>
+          <a:fillRef idx="3">
+            <a:schemeClr val="accent1"/>
+          </a:fillRef>
+          <a:effectRef idx="2">
+            <a:schemeClr val="accent1"/>
+          </a:effectRef>
+          <a:fontRef idx="minor">
+            <a:schemeClr val="lt1"/>
+          </a:fontRef>
+        </p:style>
+        <p:txBody>
+          <a:bodyPr rtlCol="0" anchor="ctr" wrap="square" lIns="50800" rIns="50800" tIns="25400" bIns="25400"/>
+          <a:lstStyle/>
+          <a:p>
+            <a:pPr algn="ctr"/>
+            <a:r>
+              <a:rPr sz="1500" b="1">
+                <a:solidFill>
+                  <a:srgbClr val="FFFFFF"/>
+                </a:solidFill>
+                <a:latin typeface="Meiryo UI"/>
+              </a:rPr>
+              <a:t>github.com/furuse-kazufumi/llcore</a:t>
+            </a:r>
+          </a:p>
+        </p:txBody>
+      </p:sp>
+      <p:sp>
+        <p:nvSpPr>
+          <p:cNvPr id="7" name="Rounded Rectangle 6"/>
+          <p:cNvSpPr/>
+          <p:nvPr/>
+        </p:nvSpPr>
+        <p:spPr>
+          <a:xfrm>
+            <a:off x="7040880" y="3017520"/>
+            <a:ext cx="4206240" cy="822960"/>
+          </a:xfrm>
+          <a:prstGeom prst="roundRect">
+            <a:avLst/>
+          </a:prstGeom>
+          <a:solidFill>
+            <a:srgbClr val="DCE6F1"/>
+          </a:solidFill>
+          <a:ln>
+            <a:noFill/>
+          </a:ln>
+        </p:spPr>
+        <p:style>
+          <a:lnRef idx="1">
+            <a:schemeClr val="accent1"/>
+          </a:lnRef>
+          <a:fillRef idx="3">
+            <a:schemeClr val="accent1"/>
+          </a:fillRef>
+          <a:effectRef idx="2">
+            <a:schemeClr val="accent1"/>
+          </a:effectRef>
+          <a:fontRef idx="minor">
+            <a:schemeClr val="lt1"/>
+          </a:fontRef>
+        </p:style>
+        <p:txBody>
+          <a:bodyPr rtlCol="0" anchor="ctr" wrap="square" lIns="50800" rIns="50800" tIns="25400" bIns="25400"/>
+          <a:lstStyle/>
+          <a:p>
+            <a:pPr algn="ctr"/>
+            <a:r>
+              <a:rPr sz="1500" b="0">
+                <a:solidFill>
+                  <a:srgbClr val="1A1A1A"/>
+                </a:solidFill>
+                <a:latin typeface="Meiryo UI"/>
+              </a:rPr>
+              <a:t>qiita.com/furuse-kazufumi</a:t>
+            </a:r>
+          </a:p>
+        </p:txBody>
+      </p:sp>
+      <p:sp>
+        <p:nvSpPr>
+          <p:cNvPr id="8" name="Rounded Rectangle 7"/>
+          <p:cNvSpPr/>
+          <p:nvPr/>
+        </p:nvSpPr>
+        <p:spPr>
+          <a:xfrm>
+            <a:off x="7040880" y="4023360"/>
+            <a:ext cx="4206240" cy="822960"/>
+          </a:xfrm>
+          <a:prstGeom prst="roundRect">
+            <a:avLst/>
+          </a:prstGeom>
+          <a:solidFill>
+            <a:srgbClr val="DCE6F1"/>
+          </a:solidFill>
+          <a:ln>
+            <a:noFill/>
+          </a:ln>
+        </p:spPr>
+        <p:style>
+          <a:lnRef idx="1">
+            <a:schemeClr val="accent1"/>
+          </a:lnRef>
+          <a:fillRef idx="3">
+            <a:schemeClr val="accent1"/>
+          </a:fillRef>
+          <a:effectRef idx="2">
+            <a:schemeClr val="accent1"/>
+          </a:effectRef>
+          <a:fontRef idx="minor">
+            <a:schemeClr val="lt1"/>
+          </a:fontRef>
+        </p:style>
+        <p:txBody>
+          <a:bodyPr rtlCol="0" anchor="ctr" wrap="square" lIns="50800" rIns="50800" tIns="25400" bIns="25400"/>
+          <a:lstStyle/>
+          <a:p>
+            <a:pPr algn="ctr"/>
+            <a:r>
+              <a:rPr sz="1400" b="0">
+                <a:solidFill>
+                  <a:srgbClr val="1A1A1A"/>
+                </a:solidFill>
+                <a:latin typeface="Meiryo UI"/>
+              </a:rPr>
+              <a:t>Commercial licensing</a:t>
+            </a:r>
+            <a:br/>
+            <a:r>
+              <a:rPr sz="1400" b="0">
+                <a:solidFill>
+                  <a:srgbClr val="1A1A1A"/>
+                </a:solidFill>
+                <a:latin typeface="Meiryo UI"/>
+              </a:rPr>
+              <a:t>kazufumi@furuse.work</a:t>
             </a:r>
           </a:p>
         </p:txBody>
@@ -3580,7 +4463,7 @@
           <a:p>
             <a:pPr algn="l"/>
             <a:r>
-              <a:rPr sz="3000" b="1">
+              <a:rPr sz="2900" b="1">
                 <a:solidFill>
                   <a:srgbClr val="1A1A1A"/>
                 </a:solidFill>
@@ -3600,7 +4483,7 @@
         <p:spPr>
           <a:xfrm>
             <a:off x="822960" y="1554480"/>
-            <a:ext cx="10607040" cy="4206240"/>
+            <a:ext cx="5577840" cy="4297680"/>
           </a:xfrm>
           <a:prstGeom prst="rect">
             <a:avLst/>
@@ -3615,65 +4498,65 @@
           <a:p>
             <a:pPr algn="l">
               <a:spcAft>
-                <a:spcPts val="1400"/>
+                <a:spcPts val="1200"/>
               </a:spcAft>
             </a:pPr>
             <a:r>
-              <a:rPr sz="1900" b="0">
+              <a:rPr sz="1700" b="0">
                 <a:solidFill>
                   <a:srgbClr val="1A1A1A"/>
                 </a:solidFill>
                 <a:latin typeface="Meiryo UI"/>
               </a:rPr>
-              <a:t>AI now evolves its own core (memory, dynamics) — how do we reject dangerous changes?</a:t>
+              <a:t>AI now evolves its own core (memory, dynamics)</a:t>
             </a:r>
           </a:p>
           <a:p>
             <a:pPr algn="l">
               <a:spcAft>
-                <a:spcPts val="1400"/>
+                <a:spcPts val="1200"/>
               </a:spcAft>
             </a:pPr>
             <a:r>
-              <a:rPr sz="1900" b="0">
+              <a:rPr sz="1700" b="0">
                 <a:solidFill>
                   <a:srgbClr val="1A1A1A"/>
                 </a:solidFill>
                 <a:latin typeface="Meiryo UI"/>
               </a:rPr>
-              <a:t>Mainstream (DGM / SEAL line) = empirical gates: benchmark scores, past failures</a:t>
+              <a:t>Mainstream (DGM / SEAL) = empirical gates: post-hoc scores &amp; past failures</a:t>
             </a:r>
           </a:p>
           <a:p>
             <a:pPr algn="l">
               <a:spcAft>
-                <a:spcPts val="1400"/>
+                <a:spcPts val="1200"/>
               </a:spcAft>
             </a:pPr>
             <a:r>
-              <a:rPr sz="1900" b="0">
+              <a:rPr sz="1700" b="0">
                 <a:solidFill>
                   <a:srgbClr val="1A1A1A"/>
                 </a:solidFill>
                 <a:latin typeface="Meiryo UI"/>
               </a:rPr>
-              <a:t>Structural weakness: (1) learns by dying — pays the failure cost (2) Goodhart-able — metrics can be gamed</a:t>
+              <a:t>Structural weakness: (1) learns by dying (2) Goodhart-able</a:t>
             </a:r>
           </a:p>
           <a:p>
             <a:pPr algn="l">
               <a:spcAft>
-                <a:spcPts val="1400"/>
+                <a:spcPts val="1200"/>
               </a:spcAft>
             </a:pPr>
             <a:r>
-              <a:rPr sz="1900" b="0">
+              <a:rPr sz="1700" b="0">
                 <a:solidFill>
                   <a:srgbClr val="1A1A1A"/>
                 </a:solidFill>
                 <a:latin typeface="Meiryo UI"/>
               </a:rPr>
-              <a:t>llcore's question: if we narrow the property, can a mathematical proof be the gate?</a:t>
+              <a:t>llcore: narrow the property, and a proof can gate before evaluation</a:t>
             </a:r>
           </a:p>
         </p:txBody>
@@ -3709,6 +4592,607 @@
                 <a:latin typeface="Meiryo UI"/>
               </a:rPr>
               <a:t>© 2026 Kazufumi Furuse — CC BY 4.0 | Source: github.com/furuse-kazufumi/llcore | qiita.com/furuse-kazufumi</a:t>
+            </a:r>
+          </a:p>
+        </p:txBody>
+      </p:sp>
+      <p:sp>
+        <p:nvSpPr>
+          <p:cNvPr id="6" name="TextBox 5"/>
+          <p:cNvSpPr txBox="1"/>
+          <p:nvPr/>
+        </p:nvSpPr>
+        <p:spPr>
+          <a:xfrm>
+            <a:off x="6675120" y="1444752"/>
+            <a:ext cx="5029200" cy="320040"/>
+          </a:xfrm>
+          <a:prstGeom prst="rect">
+            <a:avLst/>
+          </a:prstGeom>
+          <a:noFill/>
+        </p:spPr>
+        <p:txBody>
+          <a:bodyPr wrap="square">
+            <a:spAutoFit/>
+          </a:bodyPr>
+          <a:lstStyle/>
+          <a:p>
+            <a:pPr algn="l"/>
+            <a:r>
+              <a:rPr sz="1300" b="1">
+                <a:solidFill>
+                  <a:srgbClr val="666666"/>
+                </a:solidFill>
+                <a:latin typeface="Meiryo UI"/>
+              </a:rPr>
+              <a:t>Empirical gate (DGM/SEAL line)</a:t>
+            </a:r>
+          </a:p>
+        </p:txBody>
+      </p:sp>
+      <p:sp>
+        <p:nvSpPr>
+          <p:cNvPr id="7" name="Rounded Rectangle 6"/>
+          <p:cNvSpPr/>
+          <p:nvPr/>
+        </p:nvSpPr>
+        <p:spPr>
+          <a:xfrm>
+            <a:off x="6675120" y="1828800"/>
+            <a:ext cx="1325880" cy="685800"/>
+          </a:xfrm>
+          <a:prstGeom prst="roundRect">
+            <a:avLst/>
+          </a:prstGeom>
+          <a:solidFill>
+            <a:srgbClr val="DCE6F1"/>
+          </a:solidFill>
+          <a:ln>
+            <a:noFill/>
+          </a:ln>
+        </p:spPr>
+        <p:style>
+          <a:lnRef idx="1">
+            <a:schemeClr val="accent1"/>
+          </a:lnRef>
+          <a:fillRef idx="3">
+            <a:schemeClr val="accent1"/>
+          </a:fillRef>
+          <a:effectRef idx="2">
+            <a:schemeClr val="accent1"/>
+          </a:effectRef>
+          <a:fontRef idx="minor">
+            <a:schemeClr val="lt1"/>
+          </a:fontRef>
+        </p:style>
+        <p:txBody>
+          <a:bodyPr rtlCol="0" anchor="ctr" wrap="square" lIns="50800" rIns="50800" tIns="25400" bIns="25400"/>
+          <a:lstStyle/>
+          <a:p>
+            <a:pPr algn="ctr"/>
+            <a:r>
+              <a:rPr sz="1100" b="0">
+                <a:solidFill>
+                  <a:srgbClr val="1A1A1A"/>
+                </a:solidFill>
+                <a:latin typeface="Meiryo UI"/>
+              </a:rPr>
+              <a:t>mutate</a:t>
+            </a:r>
+          </a:p>
+        </p:txBody>
+      </p:sp>
+      <p:cxnSp>
+        <p:nvCxnSpPr>
+          <p:cNvPr id="8" name="Connector 7"/>
+          <p:cNvCxnSpPr/>
+          <p:nvPr/>
+        </p:nvCxnSpPr>
+        <p:spPr>
+          <a:xfrm>
+            <a:off x="8001000" y="2171700.0"/>
+            <a:ext cx="274320" cy="0.0"/>
+          </a:xfrm>
+          <a:prstGeom prst="line">
+            <a:avLst/>
+          </a:prstGeom>
+          <a:ln w="28575">
+            <a:solidFill>
+              <a:srgbClr val="666666"/>
+            </a:solidFill>
+            <a:tailEnd type="arrow" w="med" len="med"/>
+          </a:ln>
+        </p:spPr>
+        <p:style>
+          <a:lnRef idx="2">
+            <a:schemeClr val="accent1"/>
+          </a:lnRef>
+          <a:fillRef idx="0">
+            <a:schemeClr val="accent1"/>
+          </a:fillRef>
+          <a:effectRef idx="1">
+            <a:schemeClr val="accent1"/>
+          </a:effectRef>
+          <a:fontRef idx="minor">
+            <a:schemeClr val="tx1"/>
+          </a:fontRef>
+        </p:style>
+      </p:cxnSp>
+      <p:sp>
+        <p:nvSpPr>
+          <p:cNvPr id="9" name="Rounded Rectangle 8"/>
+          <p:cNvSpPr/>
+          <p:nvPr/>
+        </p:nvSpPr>
+        <p:spPr>
+          <a:xfrm>
+            <a:off x="8275320" y="1828800"/>
+            <a:ext cx="1325880" cy="685800"/>
+          </a:xfrm>
+          <a:prstGeom prst="roundRect">
+            <a:avLst/>
+          </a:prstGeom>
+          <a:solidFill>
+            <a:srgbClr val="D99694"/>
+          </a:solidFill>
+          <a:ln>
+            <a:noFill/>
+          </a:ln>
+        </p:spPr>
+        <p:style>
+          <a:lnRef idx="1">
+            <a:schemeClr val="accent1"/>
+          </a:lnRef>
+          <a:fillRef idx="3">
+            <a:schemeClr val="accent1"/>
+          </a:fillRef>
+          <a:effectRef idx="2">
+            <a:schemeClr val="accent1"/>
+          </a:effectRef>
+          <a:fontRef idx="minor">
+            <a:schemeClr val="lt1"/>
+          </a:fontRef>
+        </p:style>
+        <p:txBody>
+          <a:bodyPr rtlCol="0" anchor="ctr" wrap="square" lIns="50800" rIns="50800" tIns="25400" bIns="25400"/>
+          <a:lstStyle/>
+          <a:p>
+            <a:pPr algn="ctr"/>
+            <a:r>
+              <a:rPr sz="1100" b="0">
+                <a:solidFill>
+                  <a:srgbClr val="1A1A1A"/>
+                </a:solidFill>
+                <a:latin typeface="Meiryo UI"/>
+              </a:rPr>
+              <a:t>evaluate = run</a:t>
+            </a:r>
+            <a:br/>
+            <a:r>
+              <a:rPr sz="1100" b="0">
+                <a:solidFill>
+                  <a:srgbClr val="1A1A1A"/>
+                </a:solidFill>
+                <a:latin typeface="Meiryo UI"/>
+              </a:rPr>
+              <a:t>(pays deaths)</a:t>
+            </a:r>
+          </a:p>
+        </p:txBody>
+      </p:sp>
+      <p:cxnSp>
+        <p:nvCxnSpPr>
+          <p:cNvPr id="10" name="Connector 9"/>
+          <p:cNvCxnSpPr/>
+          <p:nvPr/>
+        </p:nvCxnSpPr>
+        <p:spPr>
+          <a:xfrm>
+            <a:off x="9601200" y="2171700.0"/>
+            <a:ext cx="274320" cy="0.0"/>
+          </a:xfrm>
+          <a:prstGeom prst="line">
+            <a:avLst/>
+          </a:prstGeom>
+          <a:ln w="28575">
+            <a:solidFill>
+              <a:srgbClr val="666666"/>
+            </a:solidFill>
+            <a:tailEnd type="arrow" w="med" len="med"/>
+          </a:ln>
+        </p:spPr>
+        <p:style>
+          <a:lnRef idx="2">
+            <a:schemeClr val="accent1"/>
+          </a:lnRef>
+          <a:fillRef idx="0">
+            <a:schemeClr val="accent1"/>
+          </a:fillRef>
+          <a:effectRef idx="1">
+            <a:schemeClr val="accent1"/>
+          </a:effectRef>
+          <a:fontRef idx="minor">
+            <a:schemeClr val="tx1"/>
+          </a:fontRef>
+        </p:style>
+      </p:cxnSp>
+      <p:sp>
+        <p:nvSpPr>
+          <p:cNvPr id="11" name="Rounded Rectangle 10"/>
+          <p:cNvSpPr/>
+          <p:nvPr/>
+        </p:nvSpPr>
+        <p:spPr>
+          <a:xfrm>
+            <a:off x="9875520" y="1828800"/>
+            <a:ext cx="1325880" cy="685800"/>
+          </a:xfrm>
+          <a:prstGeom prst="roundRect">
+            <a:avLst/>
+          </a:prstGeom>
+          <a:solidFill>
+            <a:srgbClr val="D99694"/>
+          </a:solidFill>
+          <a:ln>
+            <a:noFill/>
+          </a:ln>
+        </p:spPr>
+        <p:style>
+          <a:lnRef idx="1">
+            <a:schemeClr val="accent1"/>
+          </a:lnRef>
+          <a:fillRef idx="3">
+            <a:schemeClr val="accent1"/>
+          </a:fillRef>
+          <a:effectRef idx="2">
+            <a:schemeClr val="accent1"/>
+          </a:effectRef>
+          <a:fontRef idx="minor">
+            <a:schemeClr val="lt1"/>
+          </a:fontRef>
+        </p:style>
+        <p:txBody>
+          <a:bodyPr rtlCol="0" anchor="ctr" wrap="square" lIns="50800" rIns="50800" tIns="25400" bIns="25400"/>
+          <a:lstStyle/>
+          <a:p>
+            <a:pPr algn="ctr"/>
+            <a:r>
+              <a:rPr sz="1100" b="0">
+                <a:solidFill>
+                  <a:srgbClr val="1A1A1A"/>
+                </a:solidFill>
+                <a:latin typeface="Meiryo UI"/>
+              </a:rPr>
+              <a:t>post-hoc score</a:t>
+            </a:r>
+            <a:br/>
+            <a:r>
+              <a:rPr sz="1100" b="0">
+                <a:solidFill>
+                  <a:srgbClr val="1A1A1A"/>
+                </a:solidFill>
+                <a:latin typeface="Meiryo UI"/>
+              </a:rPr>
+              <a:t>(Goodhart-able)</a:t>
+            </a:r>
+          </a:p>
+        </p:txBody>
+      </p:sp>
+      <p:sp>
+        <p:nvSpPr>
+          <p:cNvPr id="12" name="TextBox 11"/>
+          <p:cNvSpPr txBox="1"/>
+          <p:nvPr/>
+        </p:nvSpPr>
+        <p:spPr>
+          <a:xfrm>
+            <a:off x="6675120" y="3182112"/>
+            <a:ext cx="5029200" cy="320040"/>
+          </a:xfrm>
+          <a:prstGeom prst="rect">
+            <a:avLst/>
+          </a:prstGeom>
+          <a:noFill/>
+        </p:spPr>
+        <p:txBody>
+          <a:bodyPr wrap="square">
+            <a:spAutoFit/>
+          </a:bodyPr>
+          <a:lstStyle/>
+          <a:p>
+            <a:pPr algn="l"/>
+            <a:r>
+              <a:rPr sz="1300" b="1">
+                <a:solidFill>
+                  <a:srgbClr val="4F81BD"/>
+                </a:solidFill>
+                <a:latin typeface="Meiryo UI"/>
+              </a:rPr>
+              <a:t>Proof gate (llcore)</a:t>
+            </a:r>
+          </a:p>
+        </p:txBody>
+      </p:sp>
+      <p:sp>
+        <p:nvSpPr>
+          <p:cNvPr id="13" name="Rounded Rectangle 12"/>
+          <p:cNvSpPr/>
+          <p:nvPr/>
+        </p:nvSpPr>
+        <p:spPr>
+          <a:xfrm>
+            <a:off x="6675120" y="3566160"/>
+            <a:ext cx="1325880" cy="685800"/>
+          </a:xfrm>
+          <a:prstGeom prst="roundRect">
+            <a:avLst/>
+          </a:prstGeom>
+          <a:solidFill>
+            <a:srgbClr val="DCE6F1"/>
+          </a:solidFill>
+          <a:ln>
+            <a:noFill/>
+          </a:ln>
+        </p:spPr>
+        <p:style>
+          <a:lnRef idx="1">
+            <a:schemeClr val="accent1"/>
+          </a:lnRef>
+          <a:fillRef idx="3">
+            <a:schemeClr val="accent1"/>
+          </a:fillRef>
+          <a:effectRef idx="2">
+            <a:schemeClr val="accent1"/>
+          </a:effectRef>
+          <a:fontRef idx="minor">
+            <a:schemeClr val="lt1"/>
+          </a:fontRef>
+        </p:style>
+        <p:txBody>
+          <a:bodyPr rtlCol="0" anchor="ctr" wrap="square" lIns="50800" rIns="50800" tIns="25400" bIns="25400"/>
+          <a:lstStyle/>
+          <a:p>
+            <a:pPr algn="ctr"/>
+            <a:r>
+              <a:rPr sz="1100" b="0">
+                <a:solidFill>
+                  <a:srgbClr val="1A1A1A"/>
+                </a:solidFill>
+                <a:latin typeface="Meiryo UI"/>
+              </a:rPr>
+              <a:t>mutate</a:t>
+            </a:r>
+          </a:p>
+        </p:txBody>
+      </p:sp>
+      <p:cxnSp>
+        <p:nvCxnSpPr>
+          <p:cNvPr id="14" name="Connector 13"/>
+          <p:cNvCxnSpPr/>
+          <p:nvPr/>
+        </p:nvCxnSpPr>
+        <p:spPr>
+          <a:xfrm>
+            <a:off x="8001000" y="3909060.0"/>
+            <a:ext cx="274320" cy="0.0"/>
+          </a:xfrm>
+          <a:prstGeom prst="line">
+            <a:avLst/>
+          </a:prstGeom>
+          <a:ln w="28575">
+            <a:solidFill>
+              <a:srgbClr val="666666"/>
+            </a:solidFill>
+            <a:tailEnd type="arrow" w="med" len="med"/>
+          </a:ln>
+        </p:spPr>
+        <p:style>
+          <a:lnRef idx="2">
+            <a:schemeClr val="accent1"/>
+          </a:lnRef>
+          <a:fillRef idx="0">
+            <a:schemeClr val="accent1"/>
+          </a:fillRef>
+          <a:effectRef idx="1">
+            <a:schemeClr val="accent1"/>
+          </a:effectRef>
+          <a:fontRef idx="minor">
+            <a:schemeClr val="tx1"/>
+          </a:fontRef>
+        </p:style>
+      </p:cxnSp>
+      <p:sp>
+        <p:nvSpPr>
+          <p:cNvPr id="15" name="Rounded Rectangle 14"/>
+          <p:cNvSpPr/>
+          <p:nvPr/>
+        </p:nvSpPr>
+        <p:spPr>
+          <a:xfrm>
+            <a:off x="8275320" y="3566160"/>
+            <a:ext cx="1325880" cy="685800"/>
+          </a:xfrm>
+          <a:prstGeom prst="roundRect">
+            <a:avLst/>
+          </a:prstGeom>
+          <a:solidFill>
+            <a:srgbClr val="4F81BD"/>
+          </a:solidFill>
+          <a:ln>
+            <a:noFill/>
+          </a:ln>
+        </p:spPr>
+        <p:style>
+          <a:lnRef idx="1">
+            <a:schemeClr val="accent1"/>
+          </a:lnRef>
+          <a:fillRef idx="3">
+            <a:schemeClr val="accent1"/>
+          </a:fillRef>
+          <a:effectRef idx="2">
+            <a:schemeClr val="accent1"/>
+          </a:effectRef>
+          <a:fontRef idx="minor">
+            <a:schemeClr val="lt1"/>
+          </a:fontRef>
+        </p:style>
+        <p:txBody>
+          <a:bodyPr rtlCol="0" anchor="ctr" wrap="square" lIns="50800" rIns="50800" tIns="25400" bIns="25400"/>
+          <a:lstStyle/>
+          <a:p>
+            <a:pPr algn="ctr"/>
+            <a:r>
+              <a:rPr sz="1100" b="1">
+                <a:solidFill>
+                  <a:srgbClr val="FFFFFF"/>
+                </a:solidFill>
+                <a:latin typeface="Meiryo UI"/>
+              </a:rPr>
+              <a:t>prove ρ&lt;1</a:t>
+            </a:r>
+            <a:br/>
+            <a:r>
+              <a:rPr sz="1100" b="1">
+                <a:solidFill>
+                  <a:srgbClr val="FFFFFF"/>
+                </a:solidFill>
+                <a:latin typeface="Meiryo UI"/>
+              </a:rPr>
+              <a:t>(before eval)</a:t>
+            </a:r>
+          </a:p>
+        </p:txBody>
+      </p:sp>
+      <p:cxnSp>
+        <p:nvCxnSpPr>
+          <p:cNvPr id="16" name="Connector 15"/>
+          <p:cNvCxnSpPr/>
+          <p:nvPr/>
+        </p:nvCxnSpPr>
+        <p:spPr>
+          <a:xfrm>
+            <a:off x="9601200" y="3909060.0"/>
+            <a:ext cx="274320" cy="0.0"/>
+          </a:xfrm>
+          <a:prstGeom prst="line">
+            <a:avLst/>
+          </a:prstGeom>
+          <a:ln w="28575">
+            <a:solidFill>
+              <a:srgbClr val="666666"/>
+            </a:solidFill>
+            <a:tailEnd type="arrow" w="med" len="med"/>
+          </a:ln>
+        </p:spPr>
+        <p:style>
+          <a:lnRef idx="2">
+            <a:schemeClr val="accent1"/>
+          </a:lnRef>
+          <a:fillRef idx="0">
+            <a:schemeClr val="accent1"/>
+          </a:fillRef>
+          <a:effectRef idx="1">
+            <a:schemeClr val="accent1"/>
+          </a:effectRef>
+          <a:fontRef idx="minor">
+            <a:schemeClr val="tx1"/>
+          </a:fontRef>
+        </p:style>
+      </p:cxnSp>
+      <p:sp>
+        <p:nvSpPr>
+          <p:cNvPr id="17" name="Rounded Rectangle 16"/>
+          <p:cNvSpPr/>
+          <p:nvPr/>
+        </p:nvSpPr>
+        <p:spPr>
+          <a:xfrm>
+            <a:off x="9875520" y="3566160"/>
+            <a:ext cx="1325880" cy="685800"/>
+          </a:xfrm>
+          <a:prstGeom prst="roundRect">
+            <a:avLst/>
+          </a:prstGeom>
+          <a:solidFill>
+            <a:srgbClr val="9BBB59"/>
+          </a:solidFill>
+          <a:ln>
+            <a:noFill/>
+          </a:ln>
+        </p:spPr>
+        <p:style>
+          <a:lnRef idx="1">
+            <a:schemeClr val="accent1"/>
+          </a:lnRef>
+          <a:fillRef idx="3">
+            <a:schemeClr val="accent1"/>
+          </a:fillRef>
+          <a:effectRef idx="2">
+            <a:schemeClr val="accent1"/>
+          </a:effectRef>
+          <a:fontRef idx="minor">
+            <a:schemeClr val="lt1"/>
+          </a:fontRef>
+        </p:style>
+        <p:txBody>
+          <a:bodyPr rtlCol="0" anchor="ctr" wrap="square" lIns="50800" rIns="50800" tIns="25400" bIns="25400"/>
+          <a:lstStyle/>
+          <a:p>
+            <a:pPr algn="ctr"/>
+            <a:r>
+              <a:rPr sz="1100" b="0">
+                <a:solidFill>
+                  <a:srgbClr val="1A1A1A"/>
+                </a:solidFill>
+                <a:latin typeface="Meiryo UI"/>
+              </a:rPr>
+              <a:t>evaluate</a:t>
+            </a:r>
+            <a:br/>
+            <a:r>
+              <a:rPr sz="1100" b="0">
+                <a:solidFill>
+                  <a:srgbClr val="1A1A1A"/>
+                </a:solidFill>
+                <a:latin typeface="Meiryo UI"/>
+              </a:rPr>
+              <a:t>(no deaths)</a:t>
+            </a:r>
+          </a:p>
+        </p:txBody>
+      </p:sp>
+      <p:sp>
+        <p:nvSpPr>
+          <p:cNvPr id="18" name="TextBox 17"/>
+          <p:cNvSpPr txBox="1"/>
+          <p:nvPr/>
+        </p:nvSpPr>
+        <p:spPr>
+          <a:xfrm>
+            <a:off x="6675120" y="4389120"/>
+            <a:ext cx="5029200" cy="365760"/>
+          </a:xfrm>
+          <a:prstGeom prst="rect">
+            <a:avLst/>
+          </a:prstGeom>
+          <a:noFill/>
+        </p:spPr>
+        <p:txBody>
+          <a:bodyPr wrap="square">
+            <a:spAutoFit/>
+          </a:bodyPr>
+          <a:lstStyle/>
+          <a:p>
+            <a:pPr algn="l"/>
+            <a:r>
+              <a:rPr sz="1200" b="0">
+                <a:solidFill>
+                  <a:srgbClr val="666666"/>
+                </a:solidFill>
+                <a:latin typeface="Meiryo UI"/>
+              </a:rPr>
+              <a:t>Unprovable changes rejected before evaluation (fail-closed)</a:t>
             </a:r>
           </a:p>
         </p:txBody>
@@ -3798,7 +5282,7 @@
           <a:p>
             <a:pPr algn="l"/>
             <a:r>
-              <a:rPr sz="3000" b="1">
+              <a:rPr sz="2900" b="1">
                 <a:solidFill>
                   <a:srgbClr val="1A1A1A"/>
                 </a:solidFill>
@@ -3818,7 +5302,7 @@
         <p:spPr>
           <a:xfrm>
             <a:off x="822960" y="1554480"/>
-            <a:ext cx="10607040" cy="4206240"/>
+            <a:ext cx="5577840" cy="4297680"/>
           </a:xfrm>
           <a:prstGeom prst="rect">
             <a:avLst/>
@@ -3833,11 +5317,11 @@
           <a:p>
             <a:pPr algn="l">
               <a:spcAft>
-                <a:spcPts val="1400"/>
+                <a:spcPts val="1200"/>
               </a:spcAft>
             </a:pPr>
             <a:r>
-              <a:rPr sz="1900" b="0">
+              <a:rPr sz="1700" b="0">
                 <a:solidFill>
                   <a:srgbClr val="1A1A1A"/>
                 </a:solidFill>
@@ -3849,49 +5333,49 @@
           <a:p>
             <a:pPr algn="l">
               <a:spcAft>
-                <a:spcPts val="1400"/>
+                <a:spcPts val="1200"/>
               </a:spcAft>
             </a:pPr>
             <a:r>
-              <a:rPr sz="1900" b="0">
+              <a:rPr sz="1700" b="0">
                 <a:solidFill>
                   <a:srgbClr val="1A1A1A"/>
                 </a:solidFill>
                 <a:latin typeface="Meiryo UI"/>
               </a:rPr>
-              <a:t>Three sound certifiers: closed-form ∞-norm (O(n²)) → vertex 2-norm → Lyapunov SDP</a:t>
+              <a:t>Proofs are theorem-derived = non-fabricable (unlike scores)</a:t>
             </a:r>
           </a:p>
           <a:p>
             <a:pPr algn="l">
               <a:spcAft>
-                <a:spcPts val="1400"/>
+                <a:spcPts val="1200"/>
               </a:spcAft>
             </a:pPr>
             <a:r>
-              <a:rPr sz="1900" b="0">
+              <a:rPr sz="1700" b="0">
                 <a:solidFill>
                   <a:srgbClr val="1A1A1A"/>
                 </a:solidFill>
                 <a:latin typeface="Meiryo UI"/>
               </a:rPr>
-              <a:t>Fail-closed: unprovable changes are rejected. Proofs are theorem-derived = non-fabricable</a:t>
+              <a:t>Gated in-loop, before evaluation — 17-19x cheaper than post-hoc</a:t>
             </a:r>
           </a:p>
           <a:p>
             <a:pPr algn="l">
               <a:spcAft>
-                <a:spcPts val="1400"/>
+                <a:spcPts val="1200"/>
               </a:spcAft>
             </a:pPr>
             <a:r>
-              <a:rPr sz="1900" b="0">
+              <a:rPr sz="1700" b="0">
                 <a:solidFill>
                   <a:srgbClr val="1A1A1A"/>
                 </a:solidFill>
                 <a:latin typeface="Meiryo UI"/>
               </a:rPr>
-              <a:t>Gating inside the evolution loop, before evaluation — 17-19x cheaper than post-hoc certification</a:t>
+              <a:t>All experiments pre-registered; negatives disclosed at full strength</a:t>
             </a:r>
           </a:p>
         </p:txBody>
@@ -3904,8 +5388,8 @@
         </p:nvSpPr>
         <p:spPr>
           <a:xfrm>
-            <a:off x="822960" y="5715000"/>
-            <a:ext cx="10607040" cy="457200"/>
+            <a:off x="822960" y="6400800"/>
+            <a:ext cx="10607040" cy="365760"/>
           </a:xfrm>
           <a:prstGeom prst="rect">
             <a:avLst/>
@@ -3920,27 +5404,235 @@
           <a:p>
             <a:pPr algn="l"/>
             <a:r>
-              <a:rPr sz="1200" b="0">
+              <a:rPr sz="1000" b="0">
                 <a:solidFill>
                   <a:srgbClr val="666666"/>
                 </a:solidFill>
                 <a:latin typeface="Meiryo UI"/>
               </a:rPr>
-              <a:t>All proofs &amp; experiments pre-registered before results (research/paper/PAPER_DRAFT.md)</a:t>
-            </a:r>
-          </a:p>
-        </p:txBody>
-      </p:sp>
-      <p:sp>
-        <p:nvSpPr>
-          <p:cNvPr id="6" name="TextBox 5"/>
+              <a:t>© 2026 Kazufumi Furuse — CC BY 4.0 | Source: github.com/furuse-kazufumi/llcore | qiita.com/furuse-kazufumi</a:t>
+            </a:r>
+          </a:p>
+        </p:txBody>
+      </p:sp>
+      <p:sp>
+        <p:nvSpPr>
+          <p:cNvPr id="6" name="Rounded Rectangle 5"/>
+          <p:cNvSpPr/>
+          <p:nvPr/>
+        </p:nvSpPr>
+        <p:spPr>
+          <a:xfrm>
+            <a:off x="6949440" y="1920240"/>
+            <a:ext cx="3931920" cy="640080"/>
+          </a:xfrm>
+          <a:prstGeom prst="roundRect">
+            <a:avLst/>
+          </a:prstGeom>
+          <a:solidFill>
+            <a:srgbClr val="DCE6F1"/>
+          </a:solidFill>
+          <a:ln>
+            <a:noFill/>
+          </a:ln>
+        </p:spPr>
+        <p:style>
+          <a:lnRef idx="1">
+            <a:schemeClr val="accent1"/>
+          </a:lnRef>
+          <a:fillRef idx="3">
+            <a:schemeClr val="accent1"/>
+          </a:fillRef>
+          <a:effectRef idx="2">
+            <a:schemeClr val="accent1"/>
+          </a:effectRef>
+          <a:fontRef idx="minor">
+            <a:schemeClr val="lt1"/>
+          </a:fontRef>
+        </p:style>
+        <p:txBody>
+          <a:bodyPr rtlCol="0" anchor="ctr" wrap="square" lIns="50800" rIns="50800" tIns="25400" bIns="25400"/>
+          <a:lstStyle/>
+          <a:p>
+            <a:pPr algn="ctr"/>
+            <a:r>
+              <a:rPr sz="1300" b="0">
+                <a:solidFill>
+                  <a:srgbClr val="1A1A1A"/>
+                </a:solidFill>
+                <a:latin typeface="Meiryo UI"/>
+              </a:rPr>
+              <a:t>closed-form ∞-norm — O(n²), no solver</a:t>
+            </a:r>
+          </a:p>
+        </p:txBody>
+      </p:sp>
+      <p:sp>
+        <p:nvSpPr>
+          <p:cNvPr id="7" name="Rounded Rectangle 6"/>
+          <p:cNvSpPr/>
+          <p:nvPr/>
+        </p:nvSpPr>
+        <p:spPr>
+          <a:xfrm>
+            <a:off x="7178040" y="2788920"/>
+            <a:ext cx="3931920" cy="640080"/>
+          </a:xfrm>
+          <a:prstGeom prst="roundRect">
+            <a:avLst/>
+          </a:prstGeom>
+          <a:solidFill>
+            <a:srgbClr val="DCE6F1"/>
+          </a:solidFill>
+          <a:ln>
+            <a:noFill/>
+          </a:ln>
+        </p:spPr>
+        <p:style>
+          <a:lnRef idx="1">
+            <a:schemeClr val="accent1"/>
+          </a:lnRef>
+          <a:fillRef idx="3">
+            <a:schemeClr val="accent1"/>
+          </a:fillRef>
+          <a:effectRef idx="2">
+            <a:schemeClr val="accent1"/>
+          </a:effectRef>
+          <a:fontRef idx="minor">
+            <a:schemeClr val="lt1"/>
+          </a:fontRef>
+        </p:style>
+        <p:txBody>
+          <a:bodyPr rtlCol="0" anchor="ctr" wrap="square" lIns="50800" rIns="50800" tIns="25400" bIns="25400"/>
+          <a:lstStyle/>
+          <a:p>
+            <a:pPr algn="ctr"/>
+            <a:r>
+              <a:rPr sz="1300" b="0">
+                <a:solidFill>
+                  <a:srgbClr val="1A1A1A"/>
+                </a:solidFill>
+                <a:latin typeface="Meiryo UI"/>
+              </a:rPr>
+              <a:t>vertex 2-norm (SVD)</a:t>
+            </a:r>
+          </a:p>
+        </p:txBody>
+      </p:sp>
+      <p:sp>
+        <p:nvSpPr>
+          <p:cNvPr id="8" name="Rounded Rectangle 7"/>
+          <p:cNvSpPr/>
+          <p:nvPr/>
+        </p:nvSpPr>
+        <p:spPr>
+          <a:xfrm>
+            <a:off x="7406640" y="3657600"/>
+            <a:ext cx="3931920" cy="640080"/>
+          </a:xfrm>
+          <a:prstGeom prst="roundRect">
+            <a:avLst/>
+          </a:prstGeom>
+          <a:solidFill>
+            <a:srgbClr val="DCE6F1"/>
+          </a:solidFill>
+          <a:ln>
+            <a:noFill/>
+          </a:ln>
+        </p:spPr>
+        <p:style>
+          <a:lnRef idx="1">
+            <a:schemeClr val="accent1"/>
+          </a:lnRef>
+          <a:fillRef idx="3">
+            <a:schemeClr val="accent1"/>
+          </a:fillRef>
+          <a:effectRef idx="2">
+            <a:schemeClr val="accent1"/>
+          </a:effectRef>
+          <a:fontRef idx="minor">
+            <a:schemeClr val="lt1"/>
+          </a:fontRef>
+        </p:style>
+        <p:txBody>
+          <a:bodyPr rtlCol="0" anchor="ctr" wrap="square" lIns="50800" rIns="50800" tIns="25400" bIns="25400"/>
+          <a:lstStyle/>
+          <a:p>
+            <a:pPr algn="ctr"/>
+            <a:r>
+              <a:rPr sz="1300" b="0">
+                <a:solidFill>
+                  <a:srgbClr val="1A1A1A"/>
+                </a:solidFill>
+                <a:latin typeface="Meiryo UI"/>
+              </a:rPr>
+              <a:t>Lyapunov SDP (CLARABEL)</a:t>
+            </a:r>
+          </a:p>
+        </p:txBody>
+      </p:sp>
+      <p:sp>
+        <p:nvSpPr>
+          <p:cNvPr id="9" name="Rounded Rectangle 8"/>
+          <p:cNvSpPr/>
+          <p:nvPr/>
+        </p:nvSpPr>
+        <p:spPr>
+          <a:xfrm>
+            <a:off x="7406640" y="4617720"/>
+            <a:ext cx="3931920" cy="640080"/>
+          </a:xfrm>
+          <a:prstGeom prst="roundRect">
+            <a:avLst/>
+          </a:prstGeom>
+          <a:solidFill>
+            <a:srgbClr val="4F81BD"/>
+          </a:solidFill>
+          <a:ln>
+            <a:noFill/>
+          </a:ln>
+        </p:spPr>
+        <p:style>
+          <a:lnRef idx="1">
+            <a:schemeClr val="accent1"/>
+          </a:lnRef>
+          <a:fillRef idx="3">
+            <a:schemeClr val="accent1"/>
+          </a:fillRef>
+          <a:effectRef idx="2">
+            <a:schemeClr val="accent1"/>
+          </a:effectRef>
+          <a:fontRef idx="minor">
+            <a:schemeClr val="lt1"/>
+          </a:fontRef>
+        </p:style>
+        <p:txBody>
+          <a:bodyPr rtlCol="0" anchor="ctr" wrap="square" lIns="50800" rIns="50800" tIns="25400" bIns="25400"/>
+          <a:lstStyle/>
+          <a:p>
+            <a:pPr algn="ctr"/>
+            <a:r>
+              <a:rPr sz="1300" b="1">
+                <a:solidFill>
+                  <a:srgbClr val="FFFFFF"/>
+                </a:solidFill>
+                <a:latin typeface="Meiryo UI"/>
+              </a:rPr>
+              <a:t>no proof → rejected (fail-closed)</a:t>
+            </a:r>
+          </a:p>
+        </p:txBody>
+      </p:sp>
+      <p:sp>
+        <p:nvSpPr>
+          <p:cNvPr id="10" name="TextBox 9"/>
           <p:cNvSpPr txBox="1"/>
           <p:nvPr/>
         </p:nvSpPr>
         <p:spPr>
           <a:xfrm>
-            <a:off x="822960" y="6400800"/>
-            <a:ext cx="10607040" cy="365760"/>
+            <a:off x="6720840" y="1600200"/>
+            <a:ext cx="4572000" cy="320040"/>
           </a:xfrm>
           <a:prstGeom prst="rect">
             <a:avLst/>
@@ -3955,13 +5647,13 @@
           <a:p>
             <a:pPr algn="l"/>
             <a:r>
-              <a:rPr sz="1000" b="0">
+              <a:rPr sz="1200" b="0">
                 <a:solidFill>
                   <a:srgbClr val="666666"/>
                 </a:solidFill>
                 <a:latin typeface="Meiryo UI"/>
               </a:rPr>
-              <a:t>© 2026 Kazufumi Furuse — CC BY 4.0 | Source: github.com/furuse-kazufumi/llcore | qiita.com/furuse-kazufumi</a:t>
+              <a:t>Three sound certifier rungs (stronger downward)</a:t>
             </a:r>
           </a:p>
         </p:txBody>
@@ -4051,13 +5743,13 @@
           <a:p>
             <a:pPr algn="l"/>
             <a:r>
-              <a:rPr sz="3000" b="1">
+              <a:rPr sz="2900" b="1">
                 <a:solidFill>
                   <a:srgbClr val="1A1A1A"/>
                 </a:solidFill>
                 <a:latin typeface="Meiryo UI"/>
               </a:rPr>
-              <a:t>Testbed: a lethal environment x three ways experience becomes memory</a:t>
+              <a:t>Testbed: a lethal environment x three roads from experience to memory</a:t>
             </a:r>
           </a:p>
         </p:txBody>
@@ -4071,7 +5763,7 @@
         <p:spPr>
           <a:xfrm>
             <a:off x="822960" y="1554480"/>
-            <a:ext cx="10607040" cy="4206240"/>
+            <a:ext cx="5577840" cy="4297680"/>
           </a:xfrm>
           <a:prstGeom prst="rect">
             <a:avLst/>
@@ -4086,81 +5778,49 @@
           <a:p>
             <a:pPr algn="l">
               <a:spcAft>
-                <a:spcPts val="1400"/>
+                <a:spcPts val="1200"/>
               </a:spcAft>
             </a:pPr>
             <a:r>
-              <a:rPr sz="1900" b="0">
+              <a:rPr sz="1700" b="0">
                 <a:solidFill>
                   <a:srgbClr val="1A1A1A"/>
                 </a:solidFill>
                 <a:latin typeface="Meiryo UI"/>
               </a:rPr>
-              <a:t>The environment steps the recurrence gain κ by 2x → previously-safe genes diverge = death</a:t>
+              <a:t>The environment steps κ by 2x → previously-safe genes diverge = death</a:t>
             </a:r>
           </a:p>
           <a:p>
             <a:pPr algn="l">
               <a:spcAft>
-                <a:spcPts val="1400"/>
+                <a:spcPts val="1200"/>
               </a:spcAft>
             </a:pPr>
             <a:r>
-              <a:rPr sz="1900" b="0">
+              <a:rPr sz="1700" b="0">
                 <a:solidFill>
                   <a:srgbClr val="1A1A1A"/>
                 </a:solidFill>
                 <a:latin typeface="Meiryo UI"/>
               </a:rPr>
-              <a:t>ENDO (endogenous foresight): a sound self-held certificate rejects lethal changes before evaluation</a:t>
+              <a:t>Death is a real, unavoidable threat (cannot be routed around)</a:t>
             </a:r>
           </a:p>
           <a:p>
             <a:pPr algn="l">
               <a:spcAft>
-                <a:spcPts val="1400"/>
+                <a:spcPts val="1200"/>
               </a:spcAft>
             </a:pPr>
             <a:r>
-              <a:rPr sz="1900" b="0">
+              <a:rPr sz="1700" b="0">
                 <a:solidFill>
                   <a:srgbClr val="1A1A1A"/>
                 </a:solidFill>
                 <a:latin typeface="Meiryo UI"/>
               </a:rPr>
-              <a:t>REVIVE (certificate-preserving repair): dies, but is revived with its memory gene intact</a:t>
-            </a:r>
-          </a:p>
-          <a:p>
-            <a:pPr algn="l">
-              <a:spcAft>
-                <a:spcPts val="1400"/>
-              </a:spcAft>
-            </a:pPr>
-            <a:r>
-              <a:rPr sz="1900" b="0">
-                <a:solidFill>
-                  <a:srgbClr val="1A1A1A"/>
-                </a:solidFill>
-                <a:latin typeface="Meiryo UI"/>
-              </a:rPr>
-              <a:t>OBSERVE (observational): empirically avoids the neighborhood of others' observed deaths</a:t>
-            </a:r>
-          </a:p>
-          <a:p>
-            <a:pPr algn="l">
-              <a:spcAft>
-                <a:spcPts val="1400"/>
-              </a:spcAft>
-            </a:pPr>
-            <a:r>
-              <a:rPr sz="1900" b="0">
-                <a:solidFill>
-                  <a:srgbClr val="1A1A1A"/>
-                </a:solidFill>
-                <a:latin typeface="Meiryo UI"/>
-              </a:rPr>
-              <a:t>n=20 seeds, pre-registered, steady-state after warm-up (all negatives disclosed)</a:t>
+              <a:t>Measured in the steady state after warm-up (n=20 seeds, pre-registered)</a:t>
             </a:r>
           </a:p>
         </p:txBody>
@@ -4196,6 +5856,402 @@
                 <a:latin typeface="Meiryo UI"/>
               </a:rPr>
               <a:t>© 2026 Kazufumi Furuse — CC BY 4.0 | Source: github.com/furuse-kazufumi/llcore | qiita.com/furuse-kazufumi</a:t>
+            </a:r>
+          </a:p>
+        </p:txBody>
+      </p:sp>
+      <p:cxnSp>
+        <p:nvCxnSpPr>
+          <p:cNvPr id="6" name="Connector 5"/>
+          <p:cNvCxnSpPr/>
+          <p:nvPr/>
+        </p:nvCxnSpPr>
+        <p:spPr>
+          <a:xfrm>
+            <a:off x="6675120" y="2651760"/>
+            <a:ext cx="2194560" cy="0"/>
+          </a:xfrm>
+          <a:prstGeom prst="line">
+            <a:avLst/>
+          </a:prstGeom>
+          <a:ln w="38100">
+            <a:solidFill>
+              <a:srgbClr val="4F81BD"/>
+            </a:solidFill>
+          </a:ln>
+        </p:spPr>
+        <p:style>
+          <a:lnRef idx="2">
+            <a:schemeClr val="accent1"/>
+          </a:lnRef>
+          <a:fillRef idx="0">
+            <a:schemeClr val="accent1"/>
+          </a:fillRef>
+          <a:effectRef idx="1">
+            <a:schemeClr val="accent1"/>
+          </a:effectRef>
+          <a:fontRef idx="minor">
+            <a:schemeClr val="tx1"/>
+          </a:fontRef>
+        </p:style>
+      </p:cxnSp>
+      <p:cxnSp>
+        <p:nvCxnSpPr>
+          <p:cNvPr id="7" name="Connector 6"/>
+          <p:cNvCxnSpPr/>
+          <p:nvPr/>
+        </p:nvCxnSpPr>
+        <p:spPr>
+          <a:xfrm flipV="1">
+            <a:off x="8869680" y="2103120"/>
+            <a:ext cx="0" cy="548640"/>
+          </a:xfrm>
+          <a:prstGeom prst="line">
+            <a:avLst/>
+          </a:prstGeom>
+          <a:ln w="38100">
+            <a:solidFill>
+              <a:srgbClr val="4F81BD"/>
+            </a:solidFill>
+          </a:ln>
+        </p:spPr>
+        <p:style>
+          <a:lnRef idx="2">
+            <a:schemeClr val="accent1"/>
+          </a:lnRef>
+          <a:fillRef idx="0">
+            <a:schemeClr val="accent1"/>
+          </a:fillRef>
+          <a:effectRef idx="1">
+            <a:schemeClr val="accent1"/>
+          </a:effectRef>
+          <a:fontRef idx="minor">
+            <a:schemeClr val="tx1"/>
+          </a:fontRef>
+        </p:style>
+      </p:cxnSp>
+      <p:cxnSp>
+        <p:nvCxnSpPr>
+          <p:cNvPr id="8" name="Connector 7"/>
+          <p:cNvCxnSpPr/>
+          <p:nvPr/>
+        </p:nvCxnSpPr>
+        <p:spPr>
+          <a:xfrm>
+            <a:off x="8869680" y="2103120"/>
+            <a:ext cx="2377440" cy="0"/>
+          </a:xfrm>
+          <a:prstGeom prst="line">
+            <a:avLst/>
+          </a:prstGeom>
+          <a:ln w="38100">
+            <a:solidFill>
+              <a:srgbClr val="4F81BD"/>
+            </a:solidFill>
+          </a:ln>
+        </p:spPr>
+        <p:style>
+          <a:lnRef idx="2">
+            <a:schemeClr val="accent1"/>
+          </a:lnRef>
+          <a:fillRef idx="0">
+            <a:schemeClr val="accent1"/>
+          </a:fillRef>
+          <a:effectRef idx="1">
+            <a:schemeClr val="accent1"/>
+          </a:effectRef>
+          <a:fontRef idx="minor">
+            <a:schemeClr val="tx1"/>
+          </a:fontRef>
+        </p:style>
+      </p:cxnSp>
+      <p:sp>
+        <p:nvSpPr>
+          <p:cNvPr id="9" name="TextBox 8"/>
+          <p:cNvSpPr txBox="1"/>
+          <p:nvPr/>
+        </p:nvSpPr>
+        <p:spPr>
+          <a:xfrm>
+            <a:off x="6675120" y="2697480"/>
+            <a:ext cx="2011680" cy="274320"/>
+          </a:xfrm>
+          <a:prstGeom prst="rect">
+            <a:avLst/>
+          </a:prstGeom>
+          <a:noFill/>
+        </p:spPr>
+        <p:txBody>
+          <a:bodyPr wrap="square">
+            <a:spAutoFit/>
+          </a:bodyPr>
+          <a:lstStyle/>
+          <a:p>
+            <a:pPr algn="l"/>
+            <a:r>
+              <a:rPr sz="1200" b="0">
+                <a:solidFill>
+                  <a:srgbClr val="666666"/>
+                </a:solidFill>
+                <a:latin typeface="Meiryo UI"/>
+              </a:rPr>
+              <a:t>κ = 1.0 (safe)</a:t>
+            </a:r>
+          </a:p>
+        </p:txBody>
+      </p:sp>
+      <p:sp>
+        <p:nvSpPr>
+          <p:cNvPr id="10" name="TextBox 9"/>
+          <p:cNvSpPr txBox="1"/>
+          <p:nvPr/>
+        </p:nvSpPr>
+        <p:spPr>
+          <a:xfrm>
+            <a:off x="8961120" y="1783080"/>
+            <a:ext cx="2926080" cy="274320"/>
+          </a:xfrm>
+          <a:prstGeom prst="rect">
+            <a:avLst/>
+          </a:prstGeom>
+          <a:noFill/>
+        </p:spPr>
+        <p:txBody>
+          <a:bodyPr wrap="square">
+            <a:spAutoFit/>
+          </a:bodyPr>
+          <a:lstStyle/>
+          <a:p>
+            <a:pPr algn="l"/>
+            <a:r>
+              <a:rPr sz="1200" b="1">
+                <a:solidFill>
+                  <a:srgbClr val="1A1A1A"/>
+                </a:solidFill>
+                <a:latin typeface="Meiryo UI"/>
+              </a:rPr>
+              <a:t>κ = 2.0 — old-safe genes diverge = death</a:t>
+            </a:r>
+          </a:p>
+        </p:txBody>
+      </p:sp>
+      <p:sp>
+        <p:nvSpPr>
+          <p:cNvPr id="11" name="Rounded Rectangle 10"/>
+          <p:cNvSpPr/>
+          <p:nvPr/>
+        </p:nvSpPr>
+        <p:spPr>
+          <a:xfrm>
+            <a:off x="6675120" y="3566160"/>
+            <a:ext cx="1554480" cy="1051560"/>
+          </a:xfrm>
+          <a:prstGeom prst="roundRect">
+            <a:avLst/>
+          </a:prstGeom>
+          <a:solidFill>
+            <a:srgbClr val="4F81BD"/>
+          </a:solidFill>
+          <a:ln>
+            <a:noFill/>
+          </a:ln>
+        </p:spPr>
+        <p:style>
+          <a:lnRef idx="1">
+            <a:schemeClr val="accent1"/>
+          </a:lnRef>
+          <a:fillRef idx="3">
+            <a:schemeClr val="accent1"/>
+          </a:fillRef>
+          <a:effectRef idx="2">
+            <a:schemeClr val="accent1"/>
+          </a:effectRef>
+          <a:fontRef idx="minor">
+            <a:schemeClr val="lt1"/>
+          </a:fontRef>
+        </p:style>
+        <p:txBody>
+          <a:bodyPr rtlCol="0" anchor="ctr" wrap="square" lIns="50800" rIns="50800" tIns="25400" bIns="25400"/>
+          <a:lstStyle/>
+          <a:p>
+            <a:pPr algn="ctr"/>
+            <a:r>
+              <a:rPr sz="1200" b="1">
+                <a:solidFill>
+                  <a:srgbClr val="FFFFFF"/>
+                </a:solidFill>
+                <a:latin typeface="Meiryo UI"/>
+              </a:rPr>
+              <a:t>ENDO</a:t>
+            </a:r>
+            <a:br/>
+            <a:r>
+              <a:rPr sz="1200" b="1">
+                <a:solidFill>
+                  <a:srgbClr val="FFFFFF"/>
+                </a:solidFill>
+                <a:latin typeface="Meiryo UI"/>
+              </a:rPr>
+              <a:t>foresight (proof)</a:t>
+            </a:r>
+          </a:p>
+        </p:txBody>
+      </p:sp>
+      <p:sp>
+        <p:nvSpPr>
+          <p:cNvPr id="12" name="Rounded Rectangle 11"/>
+          <p:cNvSpPr/>
+          <p:nvPr/>
+        </p:nvSpPr>
+        <p:spPr>
+          <a:xfrm>
+            <a:off x="8394192" y="3566160"/>
+            <a:ext cx="1554480" cy="1051560"/>
+          </a:xfrm>
+          <a:prstGeom prst="roundRect">
+            <a:avLst/>
+          </a:prstGeom>
+          <a:solidFill>
+            <a:srgbClr val="8064A2"/>
+          </a:solidFill>
+          <a:ln>
+            <a:noFill/>
+          </a:ln>
+        </p:spPr>
+        <p:style>
+          <a:lnRef idx="1">
+            <a:schemeClr val="accent1"/>
+          </a:lnRef>
+          <a:fillRef idx="3">
+            <a:schemeClr val="accent1"/>
+          </a:fillRef>
+          <a:effectRef idx="2">
+            <a:schemeClr val="accent1"/>
+          </a:effectRef>
+          <a:fontRef idx="minor">
+            <a:schemeClr val="lt1"/>
+          </a:fontRef>
+        </p:style>
+        <p:txBody>
+          <a:bodyPr rtlCol="0" anchor="ctr" wrap="square" lIns="50800" rIns="50800" tIns="25400" bIns="25400"/>
+          <a:lstStyle/>
+          <a:p>
+            <a:pPr algn="ctr"/>
+            <a:r>
+              <a:rPr sz="1200" b="1">
+                <a:solidFill>
+                  <a:srgbClr val="FFFFFF"/>
+                </a:solidFill>
+                <a:latin typeface="Meiryo UI"/>
+              </a:rPr>
+              <a:t>REVIVE</a:t>
+            </a:r>
+            <a:br/>
+            <a:r>
+              <a:rPr sz="1200" b="1">
+                <a:solidFill>
+                  <a:srgbClr val="FFFFFF"/>
+                </a:solidFill>
+                <a:latin typeface="Meiryo UI"/>
+              </a:rPr>
+              <a:t>die→repair→revive</a:t>
+            </a:r>
+          </a:p>
+        </p:txBody>
+      </p:sp>
+      <p:sp>
+        <p:nvSpPr>
+          <p:cNvPr id="13" name="Rounded Rectangle 12"/>
+          <p:cNvSpPr/>
+          <p:nvPr/>
+        </p:nvSpPr>
+        <p:spPr>
+          <a:xfrm>
+            <a:off x="10113264" y="3566160"/>
+            <a:ext cx="1554480" cy="1051560"/>
+          </a:xfrm>
+          <a:prstGeom prst="roundRect">
+            <a:avLst/>
+          </a:prstGeom>
+          <a:solidFill>
+            <a:srgbClr val="E8A33D"/>
+          </a:solidFill>
+          <a:ln>
+            <a:noFill/>
+          </a:ln>
+        </p:spPr>
+        <p:style>
+          <a:lnRef idx="1">
+            <a:schemeClr val="accent1"/>
+          </a:lnRef>
+          <a:fillRef idx="3">
+            <a:schemeClr val="accent1"/>
+          </a:fillRef>
+          <a:effectRef idx="2">
+            <a:schemeClr val="accent1"/>
+          </a:effectRef>
+          <a:fontRef idx="minor">
+            <a:schemeClr val="lt1"/>
+          </a:fontRef>
+        </p:style>
+        <p:txBody>
+          <a:bodyPr rtlCol="0" anchor="ctr" wrap="square" lIns="50800" rIns="50800" tIns="25400" bIns="25400"/>
+          <a:lstStyle/>
+          <a:p>
+            <a:pPr algn="ctr"/>
+            <a:r>
+              <a:rPr sz="1200" b="1">
+                <a:solidFill>
+                  <a:srgbClr val="FFFFFF"/>
+                </a:solidFill>
+                <a:latin typeface="Meiryo UI"/>
+              </a:rPr>
+              <a:t>OBSERVE</a:t>
+            </a:r>
+            <a:br/>
+            <a:r>
+              <a:rPr sz="1200" b="1">
+                <a:solidFill>
+                  <a:srgbClr val="FFFFFF"/>
+                </a:solidFill>
+                <a:latin typeface="Meiryo UI"/>
+              </a:rPr>
+              <a:t>learn from others' deaths</a:t>
+            </a:r>
+          </a:p>
+        </p:txBody>
+      </p:sp>
+      <p:sp>
+        <p:nvSpPr>
+          <p:cNvPr id="14" name="TextBox 13"/>
+          <p:cNvSpPr txBox="1"/>
+          <p:nvPr/>
+        </p:nvSpPr>
+        <p:spPr>
+          <a:xfrm>
+            <a:off x="6675120" y="4754880"/>
+            <a:ext cx="5029200" cy="548640"/>
+          </a:xfrm>
+          <a:prstGeom prst="rect">
+            <a:avLst/>
+          </a:prstGeom>
+          <a:noFill/>
+        </p:spPr>
+        <p:txBody>
+          <a:bodyPr wrap="square">
+            <a:spAutoFit/>
+          </a:bodyPr>
+          <a:lstStyle/>
+          <a:p>
+            <a:pPr algn="l"/>
+            <a:r>
+              <a:rPr sz="1200" b="0">
+                <a:solidFill>
+                  <a:srgbClr val="666666"/>
+                </a:solidFill>
+                <a:latin typeface="Meiryo UI"/>
+              </a:rPr>
+              <a:t>+ baselines: NONE (no gate) / EXO (design-time frozen gate)</a:t>
             </a:r>
           </a:p>
         </p:txBody>
@@ -4285,7 +6341,7 @@
           <a:p>
             <a:pPr algn="l"/>
             <a:r>
-              <a:rPr sz="3000" b="1">
+              <a:rPr sz="2900" b="1">
                 <a:solidFill>
                   <a:srgbClr val="1A1A1A"/>
                 </a:solidFill>
@@ -4305,7 +6361,7 @@
         <p:spPr>
           <a:xfrm>
             <a:off x="822960" y="1554480"/>
-            <a:ext cx="10607040" cy="4206240"/>
+            <a:ext cx="5577840" cy="4297680"/>
           </a:xfrm>
           <a:prstGeom prst="rect">
             <a:avLst/>
@@ -4320,81 +6376,65 @@
           <a:p>
             <a:pPr algn="l">
               <a:spcAft>
-                <a:spcPts val="1400"/>
+                <a:spcPts val="1200"/>
               </a:spcAft>
             </a:pPr>
             <a:r>
-              <a:rPr sz="1900" b="0">
+              <a:rPr sz="1700" b="0">
                 <a:solidFill>
                   <a:srgbClr val="1A1A1A"/>
                 </a:solidFill>
                 <a:latin typeface="Meiryo UI"/>
               </a:rPr>
-              <a:t>Lethal evaluations (steady state, linear substrate):</a:t>
-            </a:r>
-          </a:p>
-          <a:p>
-            <a:pPr lvl="1" algn="l">
+              <a:t>The proof (ENDO) eliminates lethal evaluations entirely</a:t>
+            </a:r>
+          </a:p>
+          <a:p>
+            <a:pPr algn="l">
               <a:spcAft>
-                <a:spcPts val="1400"/>
+                <a:spcPts val="1200"/>
               </a:spcAft>
             </a:pPr>
             <a:r>
-              <a:rPr sz="1900" b="0">
+              <a:rPr sz="1700" b="0">
                 <a:solidFill>
                   <a:srgbClr val="1A1A1A"/>
                 </a:solidFill>
                 <a:latin typeface="Meiryo UI"/>
               </a:rPr>
-              <a:t>   無防備 27.2  /  観察学習 17.3  /  固定ゲート 10.2  /  証明 (ENDO) 0.0</a:t>
+              <a:t>Observational learning works — but deaths remain (17.3). Learning-by-dying is structural</a:t>
             </a:r>
           </a:p>
           <a:p>
             <a:pPr algn="l">
               <a:spcAft>
-                <a:spcPts val="1400"/>
+                <a:spcPts val="1200"/>
               </a:spcAft>
             </a:pPr>
             <a:r>
-              <a:rPr sz="1900" b="0">
+              <a:rPr sz="1700" b="0">
                 <a:solidFill>
                   <a:srgbClr val="1A1A1A"/>
                 </a:solidFill>
                 <a:latin typeface="Meiryo UI"/>
               </a:rPr>
-              <a:t>Observational learning works — but deaths remain. Learning-by-dying is a structural cost</a:t>
+              <a:t>Robust in 12/12 pre-registered configurations (seed/κ/dimension/difficulty)</a:t>
             </a:r>
           </a:p>
           <a:p>
             <a:pPr algn="l">
               <a:spcAft>
-                <a:spcPts val="1400"/>
+                <a:spcPts val="1200"/>
               </a:spcAft>
             </a:pPr>
             <a:r>
-              <a:rPr sz="1900" b="0">
+              <a:rPr sz="1700" b="0">
                 <a:solidFill>
                   <a:srgbClr val="1A1A1A"/>
                 </a:solidFill>
                 <a:latin typeface="Meiryo UI"/>
               </a:rPr>
-              <a:t>Robustness: the proof's advantage holds in 12/12 pre-registered configurations</a:t>
-            </a:r>
-          </a:p>
-          <a:p>
-            <a:pPr algn="l">
-              <a:spcAft>
-                <a:spcPts val="1400"/>
-              </a:spcAft>
-            </a:pPr>
-            <a:r>
-              <a:rPr sz="1900" b="0">
-                <a:solidFill>
-                  <a:srgbClr val="1A1A1A"/>
-                </a:solidFill>
-                <a:latin typeface="Meiryo UI"/>
-              </a:rPr>
-              <a:t>And the proof gate does not strangle memory capability (worst fitness gap 0.7%)</a:t>
+              <a:t>Memory capability is not sacrificed (worst fitness gap 0.7%)</a:t>
             </a:r>
           </a:p>
         </p:txBody>
@@ -4407,8 +6447,8 @@
         </p:nvSpPr>
         <p:spPr>
           <a:xfrm>
-            <a:off x="822960" y="5715000"/>
-            <a:ext cx="10607040" cy="457200"/>
+            <a:off x="822960" y="5897880"/>
+            <a:ext cx="10607040" cy="411480"/>
           </a:xfrm>
           <a:prstGeom prst="rect">
             <a:avLst/>
@@ -4423,13 +6463,13 @@
           <a:p>
             <a:pPr algn="l"/>
             <a:r>
-              <a:rPr sz="1200" b="0">
+              <a:rPr sz="1100" b="0">
                 <a:solidFill>
                   <a:srgbClr val="666666"/>
                 </a:solidFill>
                 <a:latin typeface="Meiryo UI"/>
               </a:rPr>
-              <a:t>p &lt; 0.001 (paired sign-flip, n=20). All numbers in public results_viability_*.json</a:t>
+              <a:t>p &lt; 0.001 (paired sign-flip, n=20)</a:t>
             </a:r>
           </a:p>
         </p:txBody>
@@ -4465,6 +6505,59 @@
                 <a:latin typeface="Meiryo UI"/>
               </a:rPr>
               <a:t>© 2026 Kazufumi Furuse — CC BY 4.0 | Source: github.com/furuse-kazufumi/llcore | qiita.com/furuse-kazufumi</a:t>
+            </a:r>
+          </a:p>
+        </p:txBody>
+      </p:sp>
+      <p:graphicFrame>
+        <p:nvGraphicFramePr>
+          <p:cNvPr id="7" name="Chart 6"/>
+          <p:cNvGraphicFramePr>
+            <a:graphicFrameLocks noGrp="1"/>
+          </p:cNvGraphicFramePr>
+          <p:nvPr/>
+        </p:nvGraphicFramePr>
+        <p:xfrm>
+          <a:off x="6675120" y="1737360"/>
+          <a:ext cx="5029200" cy="3566160"/>
+        </p:xfrm>
+        <a:graphic>
+          <a:graphicData uri="http://schemas.openxmlformats.org/drawingml/2006/chart">
+            <c:chart xmlns:c="http://schemas.openxmlformats.org/drawingml/2006/chart" r:id="rId2"/>
+          </a:graphicData>
+        </a:graphic>
+      </p:graphicFrame>
+      <p:sp>
+        <p:nvSpPr>
+          <p:cNvPr id="8" name="TextBox 7"/>
+          <p:cNvSpPr txBox="1"/>
+          <p:nvPr/>
+        </p:nvSpPr>
+        <p:spPr>
+          <a:xfrm>
+            <a:off x="6675120" y="5486400"/>
+            <a:ext cx="5029200" cy="457200"/>
+          </a:xfrm>
+          <a:prstGeom prst="rect">
+            <a:avLst/>
+          </a:prstGeom>
+          <a:noFill/>
+        </p:spPr>
+        <p:txBody>
+          <a:bodyPr wrap="square">
+            <a:spAutoFit/>
+          </a:bodyPr>
+          <a:lstStyle/>
+          <a:p>
+            <a:pPr algn="l"/>
+            <a:r>
+              <a:rPr sz="1050" b="0">
+                <a:solidFill>
+                  <a:srgbClr val="666666"/>
+                </a:solidFill>
+                <a:latin typeface="Meiryo UI"/>
+              </a:rPr>
+              <a:t>Lethal evaluations (steady state, linear substrate, n=20 mean) — data: results_viability_ab.json</a:t>
             </a:r>
           </a:p>
         </p:txBody>
@@ -4554,7 +6647,7 @@
           <a:p>
             <a:pPr algn="l"/>
             <a:r>
-              <a:rPr sz="3000" b="1">
+              <a:rPr sz="2900" b="1">
                 <a:solidFill>
                   <a:srgbClr val="1A1A1A"/>
                 </a:solidFill>
@@ -4574,7 +6667,7 @@
         <p:spPr>
           <a:xfrm>
             <a:off x="822960" y="1554480"/>
-            <a:ext cx="10607040" cy="4206240"/>
+            <a:ext cx="5577840" cy="4297680"/>
           </a:xfrm>
           <a:prstGeom prst="rect">
             <a:avLst/>
@@ -4589,65 +6682,65 @@
           <a:p>
             <a:pPr algn="l">
               <a:spcAft>
-                <a:spcPts val="1400"/>
+                <a:spcPts val="1200"/>
               </a:spcAft>
             </a:pPr>
             <a:r>
-              <a:rPr sz="1900" b="0">
+              <a:rPr sz="1700" b="0">
                 <a:solidFill>
                   <a:srgbClr val="1A1A1A"/>
                 </a:solidFill>
                 <a:latin typeface="Meiryo UI"/>
               </a:rPr>
-              <a:t>Death removes the individual — and erases the experience its genes accumulated</a:t>
+              <a:t>Death removes the individual — and erases its accumulated experience</a:t>
             </a:r>
           </a:p>
           <a:p>
             <a:pPr algn="l">
               <a:spcAft>
-                <a:spcPts val="1400"/>
+                <a:spcPts val="1200"/>
               </a:spcAft>
             </a:pPr>
             <a:r>
-              <a:rPr sz="1900" b="0">
+              <a:rPr sz="1700" b="0">
                 <a:solidFill>
                   <a:srgbClr val="1A1A1A"/>
                 </a:solidFill>
                 <a:latin typeface="Meiryo UI"/>
               </a:rPr>
-              <a:t>REVIVE dies about as often as no-gate, yet preserves significantly more population memory</a:t>
-            </a:r>
-          </a:p>
-          <a:p>
-            <a:pPr lvl="1" algn="l">
+              <a:t>REVIVE dies about as often as no-gate, yet preserves more population memory</a:t>
+            </a:r>
+          </a:p>
+          <a:p>
+            <a:pPr algn="l">
               <a:spcAft>
-                <a:spcPts val="1400"/>
+                <a:spcPts val="1200"/>
               </a:spcAft>
             </a:pPr>
             <a:r>
-              <a:rPr sz="1900" b="0">
+              <a:rPr sz="1700" b="0">
                 <a:solidFill>
                   <a:srgbClr val="1A1A1A"/>
                 </a:solidFill>
                 <a:latin typeface="Meiryo UI"/>
               </a:rPr>
-              <a:t>   集団平均適応度: 無防備 0.649 → 復活あり 0.708 (Δ=+0.060, p=0.0011)</a:t>
+              <a:t>Δ = +0.060 (p = 0.0011) — repair preserves the memory channel while safing the dynamics</a:t>
             </a:r>
           </a:p>
           <a:p>
             <a:pPr algn="l">
               <a:spcAft>
-                <a:spcPts val="1400"/>
+                <a:spcPts val="1200"/>
               </a:spcAft>
             </a:pPr>
             <a:r>
-              <a:rPr sz="1900" b="0">
+              <a:rPr sz="1700" b="0">
                 <a:solidFill>
                   <a:srgbClr val="1A1A1A"/>
                 </a:solidFill>
                 <a:latin typeface="Meiryo UI"/>
               </a:rPr>
-              <a:t>Repair preserves the memory channel while safing the dynamics — death leaves a scar, not a void</a:t>
+              <a:t>Death becomes a scar, not a void</a:t>
             </a:r>
           </a:p>
         </p:txBody>
@@ -4683,6 +6776,59 @@
                 <a:latin typeface="Meiryo UI"/>
               </a:rPr>
               <a:t>© 2026 Kazufumi Furuse — CC BY 4.0 | Source: github.com/furuse-kazufumi/llcore | qiita.com/furuse-kazufumi</a:t>
+            </a:r>
+          </a:p>
+        </p:txBody>
+      </p:sp>
+      <p:graphicFrame>
+        <p:nvGraphicFramePr>
+          <p:cNvPr id="6" name="Chart 5"/>
+          <p:cNvGraphicFramePr>
+            <a:graphicFrameLocks noGrp="1"/>
+          </p:cNvGraphicFramePr>
+          <p:nvPr/>
+        </p:nvGraphicFramePr>
+        <p:xfrm>
+          <a:off x="6675120" y="1737360"/>
+          <a:ext cx="5029200" cy="3566160"/>
+        </p:xfrm>
+        <a:graphic>
+          <a:graphicData uri="http://schemas.openxmlformats.org/drawingml/2006/chart">
+            <c:chart xmlns:c="http://schemas.openxmlformats.org/drawingml/2006/chart" r:id="rId2"/>
+          </a:graphicData>
+        </a:graphic>
+      </p:graphicFrame>
+      <p:sp>
+        <p:nvSpPr>
+          <p:cNvPr id="7" name="TextBox 6"/>
+          <p:cNvSpPr txBox="1"/>
+          <p:nvPr/>
+        </p:nvSpPr>
+        <p:spPr>
+          <a:xfrm>
+            <a:off x="6675120" y="5486400"/>
+            <a:ext cx="5029200" cy="457200"/>
+          </a:xfrm>
+          <a:prstGeom prst="rect">
+            <a:avLst/>
+          </a:prstGeom>
+          <a:noFill/>
+        </p:spPr>
+        <p:txBody>
+          <a:bodyPr wrap="square">
+            <a:spAutoFit/>
+          </a:bodyPr>
+          <a:lstStyle/>
+          <a:p>
+            <a:pPr algn="l"/>
+            <a:r>
+              <a:rPr sz="1050" b="0">
+                <a:solidFill>
+                  <a:srgbClr val="666666"/>
+                </a:solidFill>
+                <a:latin typeface="Meiryo UI"/>
+              </a:rPr>
+              <a:t>Population-mean fitness (linear). Y-axis starts at 0.60 (to make the gap visible; mind the effect size)</a:t>
             </a:r>
           </a:p>
         </p:txBody>
@@ -4772,7 +6918,7 @@
           <a:p>
             <a:pPr algn="l"/>
             <a:r>
-              <a:rPr sz="3000" b="1">
+              <a:rPr sz="2900" b="1">
                 <a:solidFill>
                   <a:srgbClr val="1A1A1A"/>
                 </a:solidFill>
@@ -4792,7 +6938,7 @@
         <p:spPr>
           <a:xfrm>
             <a:off x="822960" y="1554480"/>
-            <a:ext cx="10607040" cy="4206240"/>
+            <a:ext cx="5577840" cy="4297680"/>
           </a:xfrm>
           <a:prstGeom prst="rect">
             <a:avLst/>
@@ -4807,81 +6953,65 @@
           <a:p>
             <a:pPr algn="l">
               <a:spcAft>
-                <a:spcPts val="1400"/>
+                <a:spcPts val="1200"/>
               </a:spcAft>
             </a:pPr>
             <a:r>
-              <a:rPr sz="1900" b="0">
+              <a:rPr sz="1700" b="0">
                 <a:solidFill>
                   <a:srgbClr val="1A1A1A"/>
                 </a:solidFill>
                 <a:latin typeface="Meiryo UI"/>
               </a:rPr>
-              <a:t>All 8 mechanism combinations compared under identical conditions (2^3 factorial):</a:t>
-            </a:r>
-          </a:p>
-          <a:p>
-            <a:pPr lvl="1" algn="l">
+              <a:t>All 8 combinations compared under identical conditions (2^3 factorial)</a:t>
+            </a:r>
+          </a:p>
+          <a:p>
+            <a:pPr algn="l">
               <a:spcAft>
-                <a:spcPts val="1400"/>
+                <a:spcPts val="1200"/>
               </a:spcAft>
             </a:pPr>
             <a:r>
-              <a:rPr sz="1900" b="0">
+              <a:rPr sz="1700" b="0">
                 <a:solidFill>
                   <a:srgbClr val="1A1A1A"/>
                 </a:solidFill>
                 <a:latin typeface="Meiryo UI"/>
               </a:rPr>
-              <a:t>   証明 (E) を含む 4 組み合わせ: 全て死 0.0</a:t>
-            </a:r>
-          </a:p>
-          <a:p>
-            <a:pPr lvl="1" algn="l">
+              <a:t>All 4 proof-containing combos: zero deaths</a:t>
+            </a:r>
+          </a:p>
+          <a:p>
+            <a:pPr algn="l">
               <a:spcAft>
-                <a:spcPts val="1400"/>
+                <a:spcPts val="1200"/>
               </a:spcAft>
             </a:pPr>
             <a:r>
-              <a:rPr sz="1900" b="0">
+              <a:rPr sz="1700" b="0">
                 <a:solidFill>
                   <a:srgbClr val="1A1A1A"/>
                 </a:solidFill>
                 <a:latin typeface="Meiryo UI"/>
               </a:rPr>
-              <a:t>   証明なしの最良 = 復活+観察 (RO): 6.2 — 単独 (18.8 / 17.3) より良いが 0 には届かない</a:t>
+              <a:t>Best proof-free combo = revival+observation (6.2) — better than alone, never zero</a:t>
             </a:r>
           </a:p>
           <a:p>
             <a:pPr algn="l">
               <a:spcAft>
-                <a:spcPts val="1400"/>
+                <a:spcPts val="1200"/>
               </a:spcAft>
             </a:pPr>
             <a:r>
-              <a:rPr sz="1900" b="0">
+              <a:rPr sz="1700" b="0">
                 <a:solidFill>
                   <a:srgbClr val="1A1A1A"/>
                 </a:solidFill>
                 <a:latin typeface="Meiryo UI"/>
               </a:rPr>
-              <a:t>With the proof present, empirical mechanisms add nothing (interaction p=0.0003/0.0045)</a:t>
-            </a:r>
-          </a:p>
-          <a:p>
-            <a:pPr algn="l">
-              <a:spcAft>
-                <a:spcPts val="1400"/>
-              </a:spcAft>
-            </a:pPr>
-            <a:r>
-              <a:rPr sz="1900" b="0">
-                <a:solidFill>
-                  <a:srgbClr val="1A1A1A"/>
-                </a:solidFill>
-                <a:latin typeface="Meiryo UI"/>
-              </a:rPr>
-              <a:t>Empirical mechanisms do compose well — but only in a world without the proof</a:t>
+              <a:t>With the proof, empirical mechanisms become redundant (interaction p=0.0003/0.0045)</a:t>
             </a:r>
           </a:p>
         </p:txBody>
@@ -4917,6 +7047,59 @@
                 <a:latin typeface="Meiryo UI"/>
               </a:rPr>
               <a:t>© 2026 Kazufumi Furuse — CC BY 4.0 | Source: github.com/furuse-kazufumi/llcore | qiita.com/furuse-kazufumi</a:t>
+            </a:r>
+          </a:p>
+        </p:txBody>
+      </p:sp>
+      <p:graphicFrame>
+        <p:nvGraphicFramePr>
+          <p:cNvPr id="6" name="Chart 5"/>
+          <p:cNvGraphicFramePr>
+            <a:graphicFrameLocks noGrp="1"/>
+          </p:cNvGraphicFramePr>
+          <p:nvPr/>
+        </p:nvGraphicFramePr>
+        <p:xfrm>
+          <a:off x="6675120" y="1737360"/>
+          <a:ext cx="5029200" cy="3566160"/>
+        </p:xfrm>
+        <a:graphic>
+          <a:graphicData uri="http://schemas.openxmlformats.org/drawingml/2006/chart">
+            <c:chart xmlns:c="http://schemas.openxmlformats.org/drawingml/2006/chart" r:id="rId2"/>
+          </a:graphicData>
+        </a:graphic>
+      </p:graphicFrame>
+      <p:sp>
+        <p:nvSpPr>
+          <p:cNvPr id="7" name="TextBox 6"/>
+          <p:cNvSpPr txBox="1"/>
+          <p:nvPr/>
+        </p:nvSpPr>
+        <p:spPr>
+          <a:xfrm>
+            <a:off x="6675120" y="5486400"/>
+            <a:ext cx="5029200" cy="457200"/>
+          </a:xfrm>
+          <a:prstGeom prst="rect">
+            <a:avLst/>
+          </a:prstGeom>
+          <a:noFill/>
+        </p:spPr>
+        <p:txBody>
+          <a:bodyPr wrap="square">
+            <a:spAutoFit/>
+          </a:bodyPr>
+          <a:lstStyle/>
+          <a:p>
+            <a:pPr algn="l"/>
+            <a:r>
+              <a:rPr sz="1050" b="0">
+                <a:solidFill>
+                  <a:srgbClr val="666666"/>
+                </a:solidFill>
+                <a:latin typeface="Meiryo UI"/>
+              </a:rPr>
+              <a:t>Lethal evaluations (2^3 factorial, linear, n=20 mean). E=proof / R=revival / O=observation</a:t>
             </a:r>
           </a:p>
         </p:txBody>
@@ -5006,7 +7189,7 @@
           <a:p>
             <a:pPr algn="l"/>
             <a:r>
-              <a:rPr sz="3000" b="1">
+              <a:rPr sz="2900" b="1">
                 <a:solidFill>
                   <a:srgbClr val="1A1A1A"/>
                 </a:solidFill>
@@ -5026,7 +7209,7 @@
         <p:spPr>
           <a:xfrm>
             <a:off x="822960" y="1554480"/>
-            <a:ext cx="10607040" cy="4206240"/>
+            <a:ext cx="5577840" cy="4297680"/>
           </a:xfrm>
           <a:prstGeom prst="rect">
             <a:avLst/>
@@ -5041,65 +7224,65 @@
           <a:p>
             <a:pPr algn="l">
               <a:spcAft>
-                <a:spcPts val="1400"/>
+                <a:spcPts val="1200"/>
               </a:spcAft>
             </a:pPr>
             <a:r>
-              <a:rPr sz="1900" b="0">
+              <a:rPr sz="1700" b="0">
                 <a:solidFill>
                   <a:srgbClr val="1A1A1A"/>
                 </a:solidFill>
                 <a:latin typeface="Meiryo UI"/>
               </a:rPr>
-              <a:t>If the verifier under-senses the environment by 40%, the certificate admits a lethal band</a:t>
+              <a:t>Break the verifier's sensing, and the certificate admits a lethal band</a:t>
             </a:r>
           </a:p>
           <a:p>
             <a:pPr algn="l">
               <a:spcAft>
-                <a:spcPts val="1400"/>
+                <a:spcPts val="1200"/>
               </a:spcAft>
             </a:pPr>
             <a:r>
-              <a:rPr sz="1900" b="0">
+              <a:rPr sz="1700" b="0">
                 <a:solidFill>
                   <a:srgbClr val="1A1A1A"/>
                 </a:solidFill>
                 <a:latin typeface="Meiryo UI"/>
               </a:rPr>
-              <a:t>A trust controller using only observable evidence (admitted-then-died) can switch proof &lt;-&gt; empirical</a:t>
+              <a:t>A trust controller on observable evidence does track the regime (figure)</a:t>
             </a:r>
           </a:p>
           <a:p>
             <a:pPr algn="l">
               <a:spcAft>
-                <a:spcPts val="1400"/>
+                <a:spcPts val="1200"/>
               </a:spcAft>
             </a:pPr>
             <a:r>
-              <a:rPr sz="1900" b="0">
+              <a:rPr sz="1700" b="0">
                 <a:solidFill>
                   <a:srgbClr val="1A1A1A"/>
                 </a:solidFill>
                 <a:latin typeface="Meiryo UI"/>
               </a:rPr>
-              <a:t>But hedging pays only where premise violations are costly — a pre-registered hypothesis failed on one substrate and we report it</a:t>
+              <a:t>But hedging pays only where violations are costly — a failed hypothesis is reported as-is</a:t>
             </a:r>
           </a:p>
           <a:p>
             <a:pPr algn="l">
               <a:spcAft>
-                <a:spcPts val="1400"/>
+                <a:spcPts val="1200"/>
               </a:spcAft>
             </a:pPr>
             <a:r>
-              <a:rPr sz="1900" b="0">
+              <a:rPr sz="1700" b="0">
                 <a:solidFill>
                   <a:srgbClr val="1A1A1A"/>
                 </a:solidFill>
                 <a:latin typeface="Meiryo UI"/>
               </a:rPr>
-              <a:t>Open question: who certifies the certifier's premises? (premise monitoring)</a:t>
+              <a:t>Open question: who certifies the certifier's premises?</a:t>
             </a:r>
           </a:p>
         </p:txBody>
@@ -5112,8 +7295,8 @@
         </p:nvSpPr>
         <p:spPr>
           <a:xfrm>
-            <a:off x="822960" y="5715000"/>
-            <a:ext cx="10607040" cy="457200"/>
+            <a:off x="822960" y="5897880"/>
+            <a:ext cx="10607040" cy="411480"/>
           </a:xfrm>
           <a:prstGeom prst="rect">
             <a:avLst/>
@@ -5128,13 +7311,13 @@
           <a:p>
             <a:pPr algn="l"/>
             <a:r>
-              <a:rPr sz="1200" b="0">
+              <a:rPr sz="1100" b="0">
                 <a:solidFill>
                   <a:srgbClr val="666666"/>
                 </a:solidFill>
                 <a:latin typeface="Meiryo UI"/>
               </a:rPr>
-              <a:t>PoC scale (scalar genes, n=20) — not yet shown at real-LLM scale. No overclaim</a:t>
+              <a:t>PoC scale (scalar genes, n=20) — not yet shown at real-LLM scale</a:t>
             </a:r>
           </a:p>
         </p:txBody>
@@ -5170,6 +7353,121 @@
                 <a:latin typeface="Meiryo UI"/>
               </a:rPr>
               <a:t>© 2026 Kazufumi Furuse — CC BY 4.0 | Source: github.com/furuse-kazufumi/llcore | qiita.com/furuse-kazufumi</a:t>
+            </a:r>
+          </a:p>
+        </p:txBody>
+      </p:sp>
+      <p:sp>
+        <p:nvSpPr>
+          <p:cNvPr id="7" name="Rounded Rectangle 6"/>
+          <p:cNvSpPr/>
+          <p:nvPr/>
+        </p:nvSpPr>
+        <p:spPr>
+          <a:xfrm>
+            <a:off x="6675120" y="1783080"/>
+            <a:ext cx="5029200" cy="777240"/>
+          </a:xfrm>
+          <a:prstGeom prst="roundRect">
+            <a:avLst/>
+          </a:prstGeom>
+          <a:solidFill>
+            <a:srgbClr val="D99694"/>
+          </a:solidFill>
+          <a:ln>
+            <a:noFill/>
+          </a:ln>
+        </p:spPr>
+        <p:style>
+          <a:lnRef idx="1">
+            <a:schemeClr val="accent1"/>
+          </a:lnRef>
+          <a:fillRef idx="3">
+            <a:schemeClr val="accent1"/>
+          </a:fillRef>
+          <a:effectRef idx="2">
+            <a:schemeClr val="accent1"/>
+          </a:effectRef>
+          <a:fontRef idx="minor">
+            <a:schemeClr val="lt1"/>
+          </a:fontRef>
+        </p:style>
+        <p:txBody>
+          <a:bodyPr rtlCol="0" anchor="ctr" wrap="square" lIns="50800" rIns="50800" tIns="25400" bIns="25400"/>
+          <a:lstStyle/>
+          <a:p>
+            <a:pPr algn="ctr"/>
+            <a:r>
+              <a:rPr sz="1200" b="0">
+                <a:solidFill>
+                  <a:srgbClr val="1A1A1A"/>
+                </a:solidFill>
+                <a:latin typeface="Meiryo UI"/>
+              </a:rPr>
+              <a:t>Verifier under-senses κ by 40% (premise broken)</a:t>
+            </a:r>
+            <a:br/>
+            <a:r>
+              <a:rPr sz="1200" b="0">
+                <a:solidFill>
+                  <a:srgbClr val="1A1A1A"/>
+                </a:solidFill>
+                <a:latin typeface="Meiryo UI"/>
+              </a:rPr>
+              <a:t>→ a regime where the proof lies</a:t>
+            </a:r>
+          </a:p>
+        </p:txBody>
+      </p:sp>
+      <p:graphicFrame>
+        <p:nvGraphicFramePr>
+          <p:cNvPr id="8" name="Chart 7"/>
+          <p:cNvGraphicFramePr>
+            <a:graphicFrameLocks noGrp="1"/>
+          </p:cNvGraphicFramePr>
+          <p:nvPr/>
+        </p:nvGraphicFramePr>
+        <p:xfrm>
+          <a:off x="7223760" y="2743200"/>
+          <a:ext cx="3931920" cy="2468880"/>
+        </p:xfrm>
+        <a:graphic>
+          <a:graphicData uri="http://schemas.openxmlformats.org/drawingml/2006/chart">
+            <c:chart xmlns:c="http://schemas.openxmlformats.org/drawingml/2006/chart" r:id="rId2"/>
+          </a:graphicData>
+        </a:graphic>
+      </p:graphicFrame>
+      <p:sp>
+        <p:nvSpPr>
+          <p:cNvPr id="9" name="TextBox 8"/>
+          <p:cNvSpPr txBox="1"/>
+          <p:nvPr/>
+        </p:nvSpPr>
+        <p:spPr>
+          <a:xfrm>
+            <a:off x="6675120" y="5486400"/>
+            <a:ext cx="5029200" cy="457200"/>
+          </a:xfrm>
+          <a:prstGeom prst="rect">
+            <a:avLst/>
+          </a:prstGeom>
+          <a:noFill/>
+        </p:spPr>
+        <p:txBody>
+          <a:bodyPr wrap="square">
+            <a:spAutoFit/>
+          </a:bodyPr>
+          <a:lstStyle/>
+          <a:p>
+            <a:pPr algn="l"/>
+            <a:r>
+              <a:rPr sz="1050" b="0">
+                <a:solidFill>
+                  <a:srgbClr val="666666"/>
+                </a:solidFill>
+                <a:latin typeface="Meiryo UI"/>
+              </a:rPr>
+              <a:t>META's trust in the proof (mean, linear). Tracks the regime from admitted-then-died evidence alone</a:t>
             </a:r>
           </a:p>
         </p:txBody>
@@ -5259,7 +7557,7 @@
           <a:p>
             <a:pPr algn="l"/>
             <a:r>
-              <a:rPr sz="3000" b="1">
+              <a:rPr sz="2900" b="1">
                 <a:solidFill>
                   <a:srgbClr val="1A1A1A"/>
                 </a:solidFill>
@@ -5279,7 +7577,7 @@
         <p:spPr>
           <a:xfrm>
             <a:off x="822960" y="1554480"/>
-            <a:ext cx="10607040" cy="4206240"/>
+            <a:ext cx="5577840" cy="4297680"/>
           </a:xfrm>
           <a:prstGeom prst="rect">
             <a:avLst/>
@@ -5294,65 +7592,65 @@
           <a:p>
             <a:pPr algn="l">
               <a:spcAft>
-                <a:spcPts val="1400"/>
+                <a:spcPts val="1200"/>
               </a:spcAft>
             </a:pPr>
             <a:r>
-              <a:rPr sz="1900" b="0">
+              <a:rPr sz="1700" b="0">
                 <a:solidFill>
                   <a:srgbClr val="1A1A1A"/>
                 </a:solidFill>
                 <a:latin typeface="Meiryo UI"/>
               </a:rPr>
-              <a:t>SGM (Statistical Goedel Machine): statistical certificate over discrete task scores — probabilistic, not fabrication-proof</a:t>
+              <a:t>SGM: statistical certificate over discrete task scores — probabilistic</a:t>
             </a:r>
           </a:p>
           <a:p>
             <a:pPr algn="l">
               <a:spcAft>
-                <a:spcPts val="1400"/>
+                <a:spcPts val="1200"/>
               </a:spcAft>
             </a:pPr>
             <a:r>
-              <a:rPr sz="1900" b="0">
+              <a:rPr sz="1700" b="0">
                 <a:solidFill>
                   <a:srgbClr val="1A1A1A"/>
                 </a:solidFill>
                 <a:latin typeface="Meiryo UI"/>
               </a:rPr>
-              <a:t>SEVerA: sound Dafny-verified logical I/O contracts — discrete artifacts, not continuous internal dynamics</a:t>
+              <a:t>SEVerA: sound Dafny logical contracts — discrete I/O artifacts</a:t>
             </a:r>
           </a:p>
           <a:p>
             <a:pPr algn="l">
               <a:spcAft>
-                <a:spcPts val="1400"/>
+                <a:spcPts val="1200"/>
               </a:spcAft>
             </a:pPr>
             <a:r>
-              <a:rPr sz="1900" b="0">
+              <a:rPr sz="1700" b="0">
                 <a:solidFill>
                   <a:srgbClr val="1A1A1A"/>
                 </a:solidFill>
                 <a:latin typeface="Meiryo UI"/>
               </a:rPr>
-              <a:t>PAC limits of self-improvement (Wang et al.): generalization bounds — not stability/contraction</a:t>
+              <a:t>PAC limits (Wang+): generalization bounds — not stability</a:t>
             </a:r>
           </a:p>
           <a:p>
             <a:pPr algn="l">
               <a:spcAft>
-                <a:spcPts val="1400"/>
+                <a:spcPts val="1200"/>
               </a:spcAft>
             </a:pPr>
             <a:r>
-              <a:rPr sz="1900" b="0">
+              <a:rPr sz="1700" b="0">
                 <a:solidFill>
                   <a:srgbClr val="1A1A1A"/>
                 </a:solidFill>
                 <a:latin typeface="Meiryo UI"/>
               </a:rPr>
-              <a:t>The open quadrant — continuous memory dynamics, gated in-loop by a sound contraction proof — is what llcore occupies at PoC scale</a:t>
+              <a:t>llcore occupies the top-right quadrant (proof x continuous memory dynamics) at PoC scale</a:t>
             </a:r>
           </a:p>
         </p:txBody>
@@ -5365,8 +7663,8 @@
         </p:nvSpPr>
         <p:spPr>
           <a:xfrm>
-            <a:off x="822960" y="5715000"/>
-            <a:ext cx="10607040" cy="457200"/>
+            <a:off x="822960" y="6400800"/>
+            <a:ext cx="10607040" cy="365760"/>
           </a:xfrm>
           <a:prstGeom prst="rect">
             <a:avLst/>
@@ -5381,13 +7679,13 @@
           <a:p>
             <a:pPr algn="l"/>
             <a:r>
-              <a:rPr sz="1200" b="0">
+              <a:rPr sz="1000" b="0">
                 <a:solidFill>
                   <a:srgbClr val="666666"/>
                 </a:solidFill>
                 <a:latin typeface="Meiryo UI"/>
               </a:rPr>
-              <a:t>All three checked against primary sources with adversarial review. Full contrasts in the paper's related-work section</a:t>
+              <a:t>© 2026 Kazufumi Furuse — CC BY 4.0 | Source: github.com/furuse-kazufumi/llcore | qiita.com/furuse-kazufumi</a:t>
             </a:r>
           </a:p>
         </p:txBody>
@@ -5400,8 +7698,8 @@
         </p:nvSpPr>
         <p:spPr>
           <a:xfrm>
-            <a:off x="822960" y="6400800"/>
-            <a:ext cx="10607040" cy="365760"/>
+            <a:off x="6675120" y="1508760"/>
+            <a:ext cx="4754880" cy="274320"/>
           </a:xfrm>
           <a:prstGeom prst="rect">
             <a:avLst/>
@@ -5416,13 +7714,331 @@
           <a:p>
             <a:pPr algn="l"/>
             <a:r>
-              <a:rPr sz="1000" b="0">
+              <a:rPr sz="1100" b="0">
                 <a:solidFill>
                   <a:srgbClr val="666666"/>
                 </a:solidFill>
                 <a:latin typeface="Meiryo UI"/>
               </a:rPr>
-              <a:t>© 2026 Kazufumi Furuse — CC BY 4.0 | Source: github.com/furuse-kazufumi/llcore | qiita.com/furuse-kazufumi</a:t>
+              <a:t>object: ↑ continuous internal dynamics / ↓ discrete tasks &amp; artifacts</a:t>
+            </a:r>
+          </a:p>
+        </p:txBody>
+      </p:sp>
+      <p:sp>
+        <p:nvSpPr>
+          <p:cNvPr id="7" name="TextBox 6"/>
+          <p:cNvSpPr txBox="1"/>
+          <p:nvPr/>
+        </p:nvSpPr>
+        <p:spPr>
+          <a:xfrm>
+            <a:off x="6675120" y="5029200"/>
+            <a:ext cx="4754880" cy="274320"/>
+          </a:xfrm>
+          <a:prstGeom prst="rect">
+            <a:avLst/>
+          </a:prstGeom>
+          <a:noFill/>
+        </p:spPr>
+        <p:txBody>
+          <a:bodyPr wrap="square">
+            <a:spAutoFit/>
+          </a:bodyPr>
+          <a:lstStyle/>
+          <a:p>
+            <a:pPr algn="l"/>
+            <a:r>
+              <a:rPr sz="1100" b="0">
+                <a:solidFill>
+                  <a:srgbClr val="666666"/>
+                </a:solidFill>
+                <a:latin typeface="Meiryo UI"/>
+              </a:rPr>
+              <a:t>guarantee: ← statistical/empirical | sound deductive proof →</a:t>
+            </a:r>
+          </a:p>
+        </p:txBody>
+      </p:sp>
+      <p:sp>
+        <p:nvSpPr>
+          <p:cNvPr id="8" name="Rounded Rectangle 7"/>
+          <p:cNvSpPr/>
+          <p:nvPr/>
+        </p:nvSpPr>
+        <p:spPr>
+          <a:xfrm>
+            <a:off x="7086600" y="1828800"/>
+            <a:ext cx="2103120" cy="1554480"/>
+          </a:xfrm>
+          <a:prstGeom prst="roundRect">
+            <a:avLst/>
+          </a:prstGeom>
+          <a:solidFill>
+            <a:srgbClr val="F2F2F2"/>
+          </a:solidFill>
+          <a:ln>
+            <a:noFill/>
+          </a:ln>
+        </p:spPr>
+        <p:style>
+          <a:lnRef idx="1">
+            <a:schemeClr val="accent1"/>
+          </a:lnRef>
+          <a:fillRef idx="3">
+            <a:schemeClr val="accent1"/>
+          </a:fillRef>
+          <a:effectRef idx="2">
+            <a:schemeClr val="accent1"/>
+          </a:effectRef>
+          <a:fontRef idx="minor">
+            <a:schemeClr val="lt1"/>
+          </a:fontRef>
+        </p:style>
+        <p:txBody>
+          <a:bodyPr rtlCol="0" anchor="ctr" wrap="square" lIns="50800" rIns="50800" tIns="25400" bIns="25400"/>
+          <a:lstStyle/>
+          <a:p>
+            <a:pPr algn="ctr"/>
+            <a:r>
+              <a:rPr sz="1100" b="0">
+                <a:solidFill>
+                  <a:srgbClr val="666666"/>
+                </a:solidFill>
+                <a:latin typeface="Meiryo UI"/>
+              </a:rPr>
+              <a:t>(open)</a:t>
+            </a:r>
+            <a:br/>
+            <a:r>
+              <a:rPr sz="1100" b="0">
+                <a:solidFill>
+                  <a:srgbClr val="666666"/>
+                </a:solidFill>
+                <a:latin typeface="Meiryo UI"/>
+              </a:rPr>
+              <a:t>statistical x continuous</a:t>
+            </a:r>
+          </a:p>
+        </p:txBody>
+      </p:sp>
+      <p:sp>
+        <p:nvSpPr>
+          <p:cNvPr id="9" name="Rounded Rectangle 8"/>
+          <p:cNvSpPr/>
+          <p:nvPr/>
+        </p:nvSpPr>
+        <p:spPr>
+          <a:xfrm>
+            <a:off x="9299448" y="1828800"/>
+            <a:ext cx="2103120" cy="1554480"/>
+          </a:xfrm>
+          <a:prstGeom prst="roundRect">
+            <a:avLst/>
+          </a:prstGeom>
+          <a:solidFill>
+            <a:srgbClr val="4F81BD"/>
+          </a:solidFill>
+          <a:ln>
+            <a:noFill/>
+          </a:ln>
+        </p:spPr>
+        <p:style>
+          <a:lnRef idx="1">
+            <a:schemeClr val="accent1"/>
+          </a:lnRef>
+          <a:fillRef idx="3">
+            <a:schemeClr val="accent1"/>
+          </a:fillRef>
+          <a:effectRef idx="2">
+            <a:schemeClr val="accent1"/>
+          </a:effectRef>
+          <a:fontRef idx="minor">
+            <a:schemeClr val="lt1"/>
+          </a:fontRef>
+        </p:style>
+        <p:txBody>
+          <a:bodyPr rtlCol="0" anchor="ctr" wrap="square" lIns="50800" rIns="50800" tIns="25400" bIns="25400"/>
+          <a:lstStyle/>
+          <a:p>
+            <a:pPr algn="ctr"/>
+            <a:r>
+              <a:rPr sz="1200" b="1">
+                <a:solidFill>
+                  <a:srgbClr val="FFFFFF"/>
+                </a:solidFill>
+                <a:latin typeface="Meiryo UI"/>
+              </a:rPr>
+              <a:t>llcore (PoC)</a:t>
+            </a:r>
+            <a:br/>
+            <a:r>
+              <a:rPr sz="1200" b="1">
+                <a:solidFill>
+                  <a:srgbClr val="FFFFFF"/>
+                </a:solidFill>
+                <a:latin typeface="Meiryo UI"/>
+              </a:rPr>
+              <a:t>proof x continuous memory dynamics</a:t>
+            </a:r>
+          </a:p>
+        </p:txBody>
+      </p:sp>
+      <p:sp>
+        <p:nvSpPr>
+          <p:cNvPr id="10" name="Rounded Rectangle 9"/>
+          <p:cNvSpPr/>
+          <p:nvPr/>
+        </p:nvSpPr>
+        <p:spPr>
+          <a:xfrm>
+            <a:off x="7086600" y="3493008"/>
+            <a:ext cx="2103120" cy="1554480"/>
+          </a:xfrm>
+          <a:prstGeom prst="roundRect">
+            <a:avLst/>
+          </a:prstGeom>
+          <a:solidFill>
+            <a:srgbClr val="F2F2F2"/>
+          </a:solidFill>
+          <a:ln>
+            <a:noFill/>
+          </a:ln>
+        </p:spPr>
+        <p:style>
+          <a:lnRef idx="1">
+            <a:schemeClr val="accent1"/>
+          </a:lnRef>
+          <a:fillRef idx="3">
+            <a:schemeClr val="accent1"/>
+          </a:fillRef>
+          <a:effectRef idx="2">
+            <a:schemeClr val="accent1"/>
+          </a:effectRef>
+          <a:fontRef idx="minor">
+            <a:schemeClr val="lt1"/>
+          </a:fontRef>
+        </p:style>
+        <p:txBody>
+          <a:bodyPr rtlCol="0" anchor="ctr" wrap="square" lIns="50800" rIns="50800" tIns="25400" bIns="25400"/>
+          <a:lstStyle/>
+          <a:p>
+            <a:pPr algn="ctr"/>
+            <a:r>
+              <a:rPr sz="1100" b="0">
+                <a:solidFill>
+                  <a:srgbClr val="1A1A1A"/>
+                </a:solidFill>
+                <a:latin typeface="Meiryo UI"/>
+              </a:rPr>
+              <a:t>SGM (statistical GM)</a:t>
+            </a:r>
+            <a:br/>
+            <a:r>
+              <a:rPr sz="1100" b="0">
+                <a:solidFill>
+                  <a:srgbClr val="1A1A1A"/>
+                </a:solidFill>
+                <a:latin typeface="Meiryo UI"/>
+              </a:rPr>
+              <a:t>PAC limits (Wang+)</a:t>
+            </a:r>
+          </a:p>
+        </p:txBody>
+      </p:sp>
+      <p:sp>
+        <p:nvSpPr>
+          <p:cNvPr id="11" name="Rounded Rectangle 10"/>
+          <p:cNvSpPr/>
+          <p:nvPr/>
+        </p:nvSpPr>
+        <p:spPr>
+          <a:xfrm>
+            <a:off x="9299448" y="3493008"/>
+            <a:ext cx="2103120" cy="1554480"/>
+          </a:xfrm>
+          <a:prstGeom prst="roundRect">
+            <a:avLst/>
+          </a:prstGeom>
+          <a:solidFill>
+            <a:srgbClr val="DCE6F1"/>
+          </a:solidFill>
+          <a:ln>
+            <a:noFill/>
+          </a:ln>
+        </p:spPr>
+        <p:style>
+          <a:lnRef idx="1">
+            <a:schemeClr val="accent1"/>
+          </a:lnRef>
+          <a:fillRef idx="3">
+            <a:schemeClr val="accent1"/>
+          </a:fillRef>
+          <a:effectRef idx="2">
+            <a:schemeClr val="accent1"/>
+          </a:effectRef>
+          <a:fontRef idx="minor">
+            <a:schemeClr val="lt1"/>
+          </a:fontRef>
+        </p:style>
+        <p:txBody>
+          <a:bodyPr rtlCol="0" anchor="ctr" wrap="square" lIns="50800" rIns="50800" tIns="25400" bIns="25400"/>
+          <a:lstStyle/>
+          <a:p>
+            <a:pPr algn="ctr"/>
+            <a:r>
+              <a:rPr sz="1100" b="0">
+                <a:solidFill>
+                  <a:srgbClr val="1A1A1A"/>
+                </a:solidFill>
+                <a:latin typeface="Meiryo UI"/>
+              </a:rPr>
+              <a:t>SEVerA</a:t>
+            </a:r>
+            <a:br/>
+            <a:r>
+              <a:rPr sz="1100" b="0">
+                <a:solidFill>
+                  <a:srgbClr val="1A1A1A"/>
+                </a:solidFill>
+                <a:latin typeface="Meiryo UI"/>
+              </a:rPr>
+              <a:t>Dafny logical contracts</a:t>
+            </a:r>
+          </a:p>
+        </p:txBody>
+      </p:sp>
+      <p:sp>
+        <p:nvSpPr>
+          <p:cNvPr id="12" name="TextBox 11"/>
+          <p:cNvSpPr txBox="1"/>
+          <p:nvPr/>
+        </p:nvSpPr>
+        <p:spPr>
+          <a:xfrm>
+            <a:off x="6675120" y="5349240"/>
+            <a:ext cx="5029200" cy="457200"/>
+          </a:xfrm>
+          <a:prstGeom prst="rect">
+            <a:avLst/>
+          </a:prstGeom>
+          <a:noFill/>
+        </p:spPr>
+        <p:txBody>
+          <a:bodyPr wrap="square">
+            <a:spAutoFit/>
+          </a:bodyPr>
+          <a:lstStyle/>
+          <a:p>
+            <a:pPr algn="l"/>
+            <a:r>
+              <a:rPr sz="1050" b="0">
+                <a:solidFill>
+                  <a:srgbClr val="666666"/>
+                </a:solidFill>
+                <a:latin typeface="Meiryo UI"/>
+              </a:rPr>
+              <a:t>All three verified against primary sources (with adversarial review)</a:t>
             </a:r>
           </a:p>
         </p:txBody>

</xml_diff>

<commit_message>
auto: make_slides.py 編集前 (2026-06-07 16:53)
</commit_message>
<xml_diff>
--- a/slides/llcore_findings_2026_en.pptx
+++ b/slides/llcore_findings_2026_en.pptx
@@ -4701,7 +4701,7 @@
             <a:solidFill>
               <a:srgbClr val="666666"/>
             </a:solidFill>
-            <a:tailEnd type="arrow" w="med" len="med"/>
+            <a:tailEnd type="arrow"/>
           </a:ln>
         </p:spPr>
         <p:style>
@@ -4799,7 +4799,7 @@
             <a:solidFill>
               <a:srgbClr val="666666"/>
             </a:solidFill>
-            <a:tailEnd type="arrow" w="med" len="med"/>
+            <a:tailEnd type="arrow"/>
           </a:ln>
         </p:spPr>
         <p:style>
@@ -4984,7 +4984,7 @@
             <a:solidFill>
               <a:srgbClr val="666666"/>
             </a:solidFill>
-            <a:tailEnd type="arrow" w="med" len="med"/>
+            <a:tailEnd type="arrow"/>
           </a:ln>
         </p:spPr>
         <p:style>
@@ -5082,7 +5082,7 @@
             <a:solidFill>
               <a:srgbClr val="666666"/>
             </a:solidFill>
-            <a:tailEnd type="arrow" w="med" len="med"/>
+            <a:tailEnd type="arrow"/>
           </a:ln>
         </p:spPr>
         <p:style>

</xml_diff>